<commit_message>
metricas atualizadas no grafana
</commit_message>
<xml_diff>
--- a/docs/nopcommerce_otel.pptx
+++ b/docs/nopcommerce_otel.pptx
@@ -348,7 +348,7 @@
             <a:pPr indent="0" algn="r">
               <a:buNone/>
             </a:pPr>
-            <a:fld id="{2127345F-51FF-4601-A9EA-8F319D802034}" type="slidenum">
+            <a:fld id="{5D7CDBE7-9850-4C01-A85C-BE5C7C278440}" type="slidenum">
               <a:rPr b="0" lang="pt-PT" sz="1400" spc="-1" strike="noStrike">
                 <a:solidFill>
                   <a:srgbClr val="000000"/>
@@ -402,7 +402,7 @@
         <p:spPr>
           <a:xfrm>
             <a:off x="685800" y="1143000"/>
-            <a:ext cx="5485680" cy="3085560"/>
+            <a:ext cx="5485320" cy="3085200"/>
           </a:xfrm>
           <a:prstGeom prst="rect">
             <a:avLst/>
@@ -425,7 +425,7 @@
         <p:spPr>
           <a:xfrm>
             <a:off x="685800" y="4400640"/>
-            <a:ext cx="5485680" cy="3599640"/>
+            <a:ext cx="5485320" cy="3599280"/>
           </a:xfrm>
           <a:prstGeom prst="rect">
             <a:avLst/>
@@ -465,7 +465,7 @@
         <p:spPr>
           <a:xfrm>
             <a:off x="3884760" y="8685360"/>
-            <a:ext cx="2971080" cy="457920"/>
+            <a:ext cx="2970720" cy="457560"/>
           </a:xfrm>
           <a:prstGeom prst="rect">
             <a:avLst/>
@@ -507,7 +507,7 @@
                 <a:tab algn="l" pos="0"/>
               </a:tabLst>
             </a:pPr>
-            <a:fld id="{233FB1D6-6E83-42FF-A081-4A2FEBB9B487}" type="slidenum">
+            <a:fld id="{C826003E-A486-4C34-AEBF-1D1337BD74AB}" type="slidenum">
               <a:rPr b="0" lang="en-US" sz="1200" spc="-1" strike="noStrike">
                 <a:solidFill>
                   <a:schemeClr val="dk1"/>
@@ -561,7 +561,7 @@
         <p:spPr>
           <a:xfrm>
             <a:off x="685800" y="1143000"/>
-            <a:ext cx="5485680" cy="3085560"/>
+            <a:ext cx="5485320" cy="3085200"/>
           </a:xfrm>
           <a:prstGeom prst="rect">
             <a:avLst/>
@@ -584,7 +584,7 @@
         <p:spPr>
           <a:xfrm>
             <a:off x="685800" y="4400640"/>
-            <a:ext cx="5485680" cy="3599640"/>
+            <a:ext cx="5485320" cy="3599280"/>
           </a:xfrm>
           <a:prstGeom prst="rect">
             <a:avLst/>
@@ -624,7 +624,7 @@
         <p:spPr>
           <a:xfrm>
             <a:off x="3884760" y="8685360"/>
-            <a:ext cx="2971080" cy="457920"/>
+            <a:ext cx="2970720" cy="457560"/>
           </a:xfrm>
           <a:prstGeom prst="rect">
             <a:avLst/>
@@ -666,7 +666,7 @@
                 <a:tab algn="l" pos="0"/>
               </a:tabLst>
             </a:pPr>
-            <a:fld id="{209C6C8E-B270-4206-97B9-7AF61D433C8D}" type="slidenum">
+            <a:fld id="{B62F4673-B0BD-4F5C-B810-3070FFAD5BCF}" type="slidenum">
               <a:rPr b="0" lang="en-US" sz="1200" spc="-1" strike="noStrike">
                 <a:solidFill>
                   <a:schemeClr val="dk1"/>
@@ -720,7 +720,7 @@
         <p:spPr>
           <a:xfrm>
             <a:off x="685800" y="1143000"/>
-            <a:ext cx="5486040" cy="3085920"/>
+            <a:ext cx="5485680" cy="3085560"/>
           </a:xfrm>
           <a:prstGeom prst="rect">
             <a:avLst/>
@@ -743,7 +743,7 @@
         <p:spPr>
           <a:xfrm>
             <a:off x="685800" y="4400640"/>
-            <a:ext cx="5486040" cy="3600000"/>
+            <a:ext cx="5485680" cy="3599640"/>
           </a:xfrm>
           <a:prstGeom prst="rect">
             <a:avLst/>
@@ -783,7 +783,7 @@
         <p:spPr>
           <a:xfrm>
             <a:off x="3884760" y="8685360"/>
-            <a:ext cx="2971440" cy="458280"/>
+            <a:ext cx="2971080" cy="457920"/>
           </a:xfrm>
           <a:prstGeom prst="rect">
             <a:avLst/>
@@ -803,6 +803,9 @@
                 <a:spcPct val="100000"/>
               </a:lnSpc>
               <a:buNone/>
+              <a:tabLst>
+                <a:tab algn="l" pos="0"/>
+              </a:tabLst>
               <a:defRPr b="0" lang="en-US" sz="1200" spc="-1" strike="noStrike">
                 <a:solidFill>
                   <a:schemeClr val="dk1"/>
@@ -818,8 +821,11 @@
                 <a:spcPct val="100000"/>
               </a:lnSpc>
               <a:buNone/>
-            </a:pPr>
-            <a:fld id="{8282586C-A6F9-4766-B61D-FB3AED30B524}" type="slidenum">
+              <a:tabLst>
+                <a:tab algn="l" pos="0"/>
+              </a:tabLst>
+            </a:pPr>
+            <a:fld id="{A7338FD1-38C7-4377-9541-8723BBCBE341}" type="slidenum">
               <a:rPr b="0" lang="en-US" sz="1200" spc="-1" strike="noStrike">
                 <a:solidFill>
                   <a:schemeClr val="dk1"/>
@@ -873,7 +879,7 @@
         <p:spPr>
           <a:xfrm>
             <a:off x="685800" y="1143000"/>
-            <a:ext cx="5485680" cy="3085560"/>
+            <a:ext cx="5485320" cy="3085200"/>
           </a:xfrm>
           <a:prstGeom prst="rect">
             <a:avLst/>
@@ -896,7 +902,7 @@
         <p:spPr>
           <a:xfrm>
             <a:off x="685800" y="4400640"/>
-            <a:ext cx="5485680" cy="3599640"/>
+            <a:ext cx="5485320" cy="3599280"/>
           </a:xfrm>
           <a:prstGeom prst="rect">
             <a:avLst/>
@@ -936,7 +942,7 @@
         <p:spPr>
           <a:xfrm>
             <a:off x="3884760" y="8685360"/>
-            <a:ext cx="2971080" cy="457920"/>
+            <a:ext cx="2970720" cy="457560"/>
           </a:xfrm>
           <a:prstGeom prst="rect">
             <a:avLst/>
@@ -978,7 +984,7 @@
                 <a:tab algn="l" pos="0"/>
               </a:tabLst>
             </a:pPr>
-            <a:fld id="{08B5239B-6EFF-4C87-BFEC-367F6E339139}" type="slidenum">
+            <a:fld id="{E03F1EFB-7A59-4325-B0EA-8CF60C9AF9E9}" type="slidenum">
               <a:rPr b="0" lang="en-US" sz="1200" spc="-1" strike="noStrike">
                 <a:solidFill>
                   <a:schemeClr val="dk1"/>
@@ -1032,7 +1038,7 @@
         <p:spPr>
           <a:xfrm>
             <a:off x="685800" y="1143000"/>
-            <a:ext cx="5485680" cy="3085560"/>
+            <a:ext cx="5485320" cy="3085200"/>
           </a:xfrm>
           <a:prstGeom prst="rect">
             <a:avLst/>
@@ -1055,7 +1061,7 @@
         <p:spPr>
           <a:xfrm>
             <a:off x="685800" y="4400640"/>
-            <a:ext cx="5485680" cy="3599640"/>
+            <a:ext cx="5485320" cy="3599280"/>
           </a:xfrm>
           <a:prstGeom prst="rect">
             <a:avLst/>
@@ -1095,7 +1101,7 @@
         <p:spPr>
           <a:xfrm>
             <a:off x="3884760" y="8685360"/>
-            <a:ext cx="2971080" cy="457920"/>
+            <a:ext cx="2970720" cy="457560"/>
           </a:xfrm>
           <a:prstGeom prst="rect">
             <a:avLst/>
@@ -1137,7 +1143,7 @@
                 <a:tab algn="l" pos="0"/>
               </a:tabLst>
             </a:pPr>
-            <a:fld id="{9A0EB54F-0D82-430B-B57F-D11A269E6DBF}" type="slidenum">
+            <a:fld id="{53E6E200-BE52-4435-A535-5E4901C5D2C8}" type="slidenum">
               <a:rPr b="0" lang="en-US" sz="1200" spc="-1" strike="noStrike">
                 <a:solidFill>
                   <a:schemeClr val="dk1"/>
@@ -1191,7 +1197,7 @@
         <p:spPr>
           <a:xfrm>
             <a:off x="685800" y="1143000"/>
-            <a:ext cx="5485680" cy="3085560"/>
+            <a:ext cx="5485320" cy="3085200"/>
           </a:xfrm>
           <a:prstGeom prst="rect">
             <a:avLst/>
@@ -1214,7 +1220,7 @@
         <p:spPr>
           <a:xfrm>
             <a:off x="685800" y="4400640"/>
-            <a:ext cx="5485680" cy="3599640"/>
+            <a:ext cx="5485320" cy="3599280"/>
           </a:xfrm>
           <a:prstGeom prst="rect">
             <a:avLst/>
@@ -1254,7 +1260,7 @@
         <p:spPr>
           <a:xfrm>
             <a:off x="3884760" y="8685360"/>
-            <a:ext cx="2971080" cy="457920"/>
+            <a:ext cx="2970720" cy="457560"/>
           </a:xfrm>
           <a:prstGeom prst="rect">
             <a:avLst/>
@@ -1296,7 +1302,7 @@
                 <a:tab algn="l" pos="0"/>
               </a:tabLst>
             </a:pPr>
-            <a:fld id="{101DA4FE-ED24-4E53-B05C-F6254E126C49}" type="slidenum">
+            <a:fld id="{CB3F9FAB-A5B6-421B-92F5-C84EBB50E29C}" type="slidenum">
               <a:rPr b="0" lang="en-US" sz="1200" spc="-1" strike="noStrike">
                 <a:solidFill>
                   <a:schemeClr val="dk1"/>
@@ -1350,7 +1356,7 @@
         <p:spPr>
           <a:xfrm>
             <a:off x="685800" y="1143000"/>
-            <a:ext cx="5485680" cy="3085560"/>
+            <a:ext cx="5485320" cy="3085200"/>
           </a:xfrm>
           <a:prstGeom prst="rect">
             <a:avLst/>
@@ -1373,7 +1379,7 @@
         <p:spPr>
           <a:xfrm>
             <a:off x="685800" y="4400640"/>
-            <a:ext cx="5485680" cy="3599640"/>
+            <a:ext cx="5485320" cy="3599280"/>
           </a:xfrm>
           <a:prstGeom prst="rect">
             <a:avLst/>
@@ -1413,7 +1419,7 @@
         <p:spPr>
           <a:xfrm>
             <a:off x="3884760" y="8685360"/>
-            <a:ext cx="2971080" cy="457920"/>
+            <a:ext cx="2970720" cy="457560"/>
           </a:xfrm>
           <a:prstGeom prst="rect">
             <a:avLst/>
@@ -1455,7 +1461,7 @@
                 <a:tab algn="l" pos="0"/>
               </a:tabLst>
             </a:pPr>
-            <a:fld id="{2D122B83-0F3C-4B33-9BE9-6B0F73B1E39B}" type="slidenum">
+            <a:fld id="{88DA1071-E3A3-4D7B-84D1-6FBFCFB8EDE5}" type="slidenum">
               <a:rPr b="0" lang="en-US" sz="1200" spc="-1" strike="noStrike">
                 <a:solidFill>
                   <a:schemeClr val="dk1"/>
@@ -1509,7 +1515,7 @@
         <p:spPr>
           <a:xfrm>
             <a:off x="685800" y="1143000"/>
-            <a:ext cx="5485680" cy="3085560"/>
+            <a:ext cx="5485320" cy="3085200"/>
           </a:xfrm>
           <a:prstGeom prst="rect">
             <a:avLst/>
@@ -1532,7 +1538,7 @@
         <p:spPr>
           <a:xfrm>
             <a:off x="685800" y="4400640"/>
-            <a:ext cx="5485680" cy="3599640"/>
+            <a:ext cx="5485320" cy="3599280"/>
           </a:xfrm>
           <a:prstGeom prst="rect">
             <a:avLst/>
@@ -1572,7 +1578,7 @@
         <p:spPr>
           <a:xfrm>
             <a:off x="3884760" y="8685360"/>
-            <a:ext cx="2971080" cy="457920"/>
+            <a:ext cx="2970720" cy="457560"/>
           </a:xfrm>
           <a:prstGeom prst="rect">
             <a:avLst/>
@@ -1614,7 +1620,7 @@
                 <a:tab algn="l" pos="0"/>
               </a:tabLst>
             </a:pPr>
-            <a:fld id="{044CEC4A-048B-4006-B073-B0E534317216}" type="slidenum">
+            <a:fld id="{7A4E63FE-C55B-4994-A249-71116B340417}" type="slidenum">
               <a:rPr b="0" lang="en-US" sz="1200" spc="-1" strike="noStrike">
                 <a:solidFill>
                   <a:schemeClr val="dk1"/>
@@ -1668,7 +1674,7 @@
         <p:spPr>
           <a:xfrm>
             <a:off x="685800" y="1143000"/>
-            <a:ext cx="5485680" cy="3085560"/>
+            <a:ext cx="5485320" cy="3085200"/>
           </a:xfrm>
           <a:prstGeom prst="rect">
             <a:avLst/>
@@ -1691,7 +1697,7 @@
         <p:spPr>
           <a:xfrm>
             <a:off x="685800" y="4400640"/>
-            <a:ext cx="5485680" cy="3599640"/>
+            <a:ext cx="5485320" cy="3599280"/>
           </a:xfrm>
           <a:prstGeom prst="rect">
             <a:avLst/>
@@ -1731,7 +1737,7 @@
         <p:spPr>
           <a:xfrm>
             <a:off x="3884760" y="8685360"/>
-            <a:ext cx="2971080" cy="457920"/>
+            <a:ext cx="2970720" cy="457560"/>
           </a:xfrm>
           <a:prstGeom prst="rect">
             <a:avLst/>
@@ -1773,7 +1779,7 @@
                 <a:tab algn="l" pos="0"/>
               </a:tabLst>
             </a:pPr>
-            <a:fld id="{24DC2E18-24BF-4C38-AE55-3748FECE2991}" type="slidenum">
+            <a:fld id="{CF8E83CC-8B61-48D1-AB5D-921893140134}" type="slidenum">
               <a:rPr b="0" lang="en-US" sz="1200" spc="-1" strike="noStrike">
                 <a:solidFill>
                   <a:schemeClr val="dk1"/>
@@ -1827,7 +1833,7 @@
         <p:spPr>
           <a:xfrm>
             <a:off x="685800" y="1143000"/>
-            <a:ext cx="5485680" cy="3085560"/>
+            <a:ext cx="5485320" cy="3085200"/>
           </a:xfrm>
           <a:prstGeom prst="rect">
             <a:avLst/>
@@ -1850,7 +1856,7 @@
         <p:spPr>
           <a:xfrm>
             <a:off x="685800" y="4400640"/>
-            <a:ext cx="5485680" cy="3599640"/>
+            <a:ext cx="5485320" cy="3599280"/>
           </a:xfrm>
           <a:prstGeom prst="rect">
             <a:avLst/>
@@ -1890,7 +1896,7 @@
         <p:spPr>
           <a:xfrm>
             <a:off x="3884760" y="8685360"/>
-            <a:ext cx="2971080" cy="457920"/>
+            <a:ext cx="2970720" cy="457560"/>
           </a:xfrm>
           <a:prstGeom prst="rect">
             <a:avLst/>
@@ -1932,7 +1938,7 @@
                 <a:tab algn="l" pos="0"/>
               </a:tabLst>
             </a:pPr>
-            <a:fld id="{80CD3412-EBF4-4E1E-B31B-62444E1AAD31}" type="slidenum">
+            <a:fld id="{7B7169F3-A11F-49C6-9842-45CCAAEAA896}" type="slidenum">
               <a:rPr b="0" lang="en-US" sz="1200" spc="-1" strike="noStrike">
                 <a:solidFill>
                   <a:schemeClr val="dk1"/>
@@ -2063,8 +2069,8 @@
         </p:nvSpPr>
         <p:spPr>
           <a:xfrm>
-            <a:off x="457200" y="1203480"/>
-            <a:ext cx="8229240" cy="2983320"/>
+            <a:off x="457200" y="1203840"/>
+            <a:ext cx="8229240" cy="2983680"/>
           </a:xfrm>
           <a:prstGeom prst="rect">
             <a:avLst/>
@@ -2318,7 +2324,7 @@
         <p:spPr>
           <a:xfrm>
             <a:off x="0" y="0"/>
-            <a:ext cx="9143280" cy="49680"/>
+            <a:ext cx="9142920" cy="49320"/>
           </a:xfrm>
           <a:prstGeom prst="rect">
             <a:avLst/>
@@ -2367,7 +2373,7 @@
         <p:spPr>
           <a:xfrm>
             <a:off x="822960" y="1417320"/>
-            <a:ext cx="7497360" cy="913680"/>
+            <a:ext cx="7497000" cy="913320"/>
           </a:xfrm>
           <a:prstGeom prst="rect">
             <a:avLst/>
@@ -2424,7 +2430,7 @@
         <p:spPr>
           <a:xfrm>
             <a:off x="822960" y="2423160"/>
-            <a:ext cx="7497360" cy="502200"/>
+            <a:ext cx="7497000" cy="501840"/>
           </a:xfrm>
           <a:prstGeom prst="rect">
             <a:avLst/>
@@ -2481,7 +2487,7 @@
         <p:spPr>
           <a:xfrm>
             <a:off x="822960" y="3036240"/>
-            <a:ext cx="2010960" cy="36000"/>
+            <a:ext cx="2010600" cy="35640"/>
           </a:xfrm>
           <a:prstGeom prst="rect">
             <a:avLst/>
@@ -2530,7 +2536,7 @@
         <p:spPr>
           <a:xfrm>
             <a:off x="0" y="4814640"/>
-            <a:ext cx="9143280" cy="328320"/>
+            <a:ext cx="9142920" cy="327960"/>
           </a:xfrm>
           <a:prstGeom prst="rect">
             <a:avLst/>
@@ -2579,7 +2585,7 @@
         <p:spPr>
           <a:xfrm>
             <a:off x="365760" y="4814640"/>
-            <a:ext cx="8411760" cy="328320"/>
+            <a:ext cx="8411400" cy="327960"/>
           </a:xfrm>
           <a:prstGeom prst="rect">
             <a:avLst/>
@@ -2673,7 +2679,7 @@
         <p:spPr>
           <a:xfrm>
             <a:off x="365760" y="274320"/>
-            <a:ext cx="45000" cy="529560"/>
+            <a:ext cx="44640" cy="529200"/>
           </a:xfrm>
           <a:prstGeom prst="rect">
             <a:avLst/>
@@ -2699,6 +2705,11 @@
             <a:noAutofit/>
           </a:bodyPr>
           <a:p>
+            <a:pPr>
+              <a:lnSpc>
+                <a:spcPct val="100000"/>
+              </a:lnSpc>
+            </a:pPr>
             <a:endParaRPr b="0" lang="pt-PT" sz="1800" spc="-1" strike="noStrike">
               <a:solidFill>
                 <a:srgbClr val="ffffff"/>
@@ -2717,7 +2728,7 @@
         <p:spPr>
           <a:xfrm>
             <a:off x="502920" y="255960"/>
-            <a:ext cx="8320320" cy="593640"/>
+            <a:ext cx="8319960" cy="593280"/>
           </a:xfrm>
           <a:prstGeom prst="rect">
             <a:avLst/>
@@ -2774,7 +2785,7 @@
         <p:spPr>
           <a:xfrm>
             <a:off x="365760" y="877680"/>
-            <a:ext cx="8411760" cy="19440"/>
+            <a:ext cx="8411400" cy="19080"/>
           </a:xfrm>
           <a:prstGeom prst="rect">
             <a:avLst/>
@@ -2800,6 +2811,11 @@
             <a:noAutofit/>
           </a:bodyPr>
           <a:p>
+            <a:pPr>
+              <a:lnSpc>
+                <a:spcPct val="100000"/>
+              </a:lnSpc>
+            </a:pPr>
             <a:endParaRPr b="0" lang="pt-PT" sz="1800" spc="-1" strike="noStrike">
               <a:solidFill>
                 <a:srgbClr val="ffffff"/>
@@ -2818,7 +2834,7 @@
         <p:spPr>
           <a:xfrm>
             <a:off x="0" y="4906080"/>
-            <a:ext cx="9143280" cy="236880"/>
+            <a:ext cx="9142920" cy="236520"/>
           </a:xfrm>
           <a:prstGeom prst="rect">
             <a:avLst/>
@@ -2844,6 +2860,11 @@
             <a:noAutofit/>
           </a:bodyPr>
           <a:p>
+            <a:pPr>
+              <a:lnSpc>
+                <a:spcPct val="100000"/>
+              </a:lnSpc>
+            </a:pPr>
             <a:endParaRPr b="0" lang="pt-PT" sz="1800" spc="-1" strike="noStrike">
               <a:solidFill>
                 <a:srgbClr val="ffffff"/>
@@ -2862,7 +2883,7 @@
         <p:spPr>
           <a:xfrm>
             <a:off x="365760" y="4906080"/>
-            <a:ext cx="8411760" cy="236880"/>
+            <a:ext cx="8411400" cy="236520"/>
           </a:xfrm>
           <a:prstGeom prst="rect">
             <a:avLst/>
@@ -2919,7 +2940,7 @@
         <p:spPr>
           <a:xfrm>
             <a:off x="365760" y="987480"/>
-            <a:ext cx="2760840" cy="621000"/>
+            <a:ext cx="2760480" cy="620640"/>
           </a:xfrm>
           <a:prstGeom prst="rect">
             <a:avLst/>
@@ -2945,6 +2966,11 @@
             <a:noAutofit/>
           </a:bodyPr>
           <a:p>
+            <a:pPr>
+              <a:lnSpc>
+                <a:spcPct val="100000"/>
+              </a:lnSpc>
+            </a:pPr>
             <a:endParaRPr b="0" lang="pt-PT" sz="1800" spc="-1" strike="noStrike">
               <a:solidFill>
                 <a:srgbClr val="ffffff"/>
@@ -2963,7 +2989,7 @@
         <p:spPr>
           <a:xfrm>
             <a:off x="365760" y="987480"/>
-            <a:ext cx="45000" cy="621000"/>
+            <a:ext cx="44640" cy="620640"/>
           </a:xfrm>
           <a:prstGeom prst="rect">
             <a:avLst/>
@@ -2989,6 +3015,11 @@
             <a:noAutofit/>
           </a:bodyPr>
           <a:p>
+            <a:pPr>
+              <a:lnSpc>
+                <a:spcPct val="100000"/>
+              </a:lnSpc>
+            </a:pPr>
             <a:endParaRPr b="0" lang="pt-PT" sz="1800" spc="-1" strike="noStrike">
               <a:solidFill>
                 <a:srgbClr val="ffffff"/>
@@ -3007,7 +3038,7 @@
         <p:spPr>
           <a:xfrm>
             <a:off x="475560" y="1005840"/>
-            <a:ext cx="2559600" cy="255240"/>
+            <a:ext cx="2559240" cy="254880"/>
           </a:xfrm>
           <a:prstGeom prst="rect">
             <a:avLst/>
@@ -3064,7 +3095,7 @@
         <p:spPr>
           <a:xfrm>
             <a:off x="475560" y="1280160"/>
-            <a:ext cx="2559600" cy="273600"/>
+            <a:ext cx="2559240" cy="273240"/>
           </a:xfrm>
           <a:prstGeom prst="rect">
             <a:avLst/>
@@ -3121,7 +3152,7 @@
         <p:spPr>
           <a:xfrm>
             <a:off x="3310200" y="987480"/>
-            <a:ext cx="2760840" cy="621000"/>
+            <a:ext cx="2760480" cy="620640"/>
           </a:xfrm>
           <a:prstGeom prst="rect">
             <a:avLst/>
@@ -3147,6 +3178,11 @@
             <a:noAutofit/>
           </a:bodyPr>
           <a:p>
+            <a:pPr>
+              <a:lnSpc>
+                <a:spcPct val="100000"/>
+              </a:lnSpc>
+            </a:pPr>
             <a:endParaRPr b="0" lang="pt-PT" sz="1800" spc="-1" strike="noStrike">
               <a:solidFill>
                 <a:srgbClr val="ffffff"/>
@@ -3165,7 +3201,7 @@
         <p:spPr>
           <a:xfrm>
             <a:off x="3310200" y="987480"/>
-            <a:ext cx="45000" cy="621000"/>
+            <a:ext cx="44640" cy="620640"/>
           </a:xfrm>
           <a:prstGeom prst="rect">
             <a:avLst/>
@@ -3191,6 +3227,11 @@
             <a:noAutofit/>
           </a:bodyPr>
           <a:p>
+            <a:pPr>
+              <a:lnSpc>
+                <a:spcPct val="100000"/>
+              </a:lnSpc>
+            </a:pPr>
             <a:endParaRPr b="0" lang="pt-PT" sz="1800" spc="-1" strike="noStrike">
               <a:solidFill>
                 <a:srgbClr val="ffffff"/>
@@ -3209,7 +3250,7 @@
         <p:spPr>
           <a:xfrm>
             <a:off x="3420000" y="1005840"/>
-            <a:ext cx="2559600" cy="255240"/>
+            <a:ext cx="2559240" cy="254880"/>
           </a:xfrm>
           <a:prstGeom prst="rect">
             <a:avLst/>
@@ -3266,7 +3307,7 @@
         <p:spPr>
           <a:xfrm>
             <a:off x="3420000" y="1280160"/>
-            <a:ext cx="2559600" cy="273600"/>
+            <a:ext cx="2559240" cy="273240"/>
           </a:xfrm>
           <a:prstGeom prst="rect">
             <a:avLst/>
@@ -3323,7 +3364,7 @@
         <p:spPr>
           <a:xfrm>
             <a:off x="6254640" y="987480"/>
-            <a:ext cx="2760840" cy="621000"/>
+            <a:ext cx="2760480" cy="620640"/>
           </a:xfrm>
           <a:prstGeom prst="rect">
             <a:avLst/>
@@ -3349,6 +3390,11 @@
             <a:noAutofit/>
           </a:bodyPr>
           <a:p>
+            <a:pPr>
+              <a:lnSpc>
+                <a:spcPct val="100000"/>
+              </a:lnSpc>
+            </a:pPr>
             <a:endParaRPr b="0" lang="pt-PT" sz="1800" spc="-1" strike="noStrike">
               <a:solidFill>
                 <a:srgbClr val="ffffff"/>
@@ -3367,7 +3413,7 @@
         <p:spPr>
           <a:xfrm>
             <a:off x="6254640" y="987480"/>
-            <a:ext cx="45000" cy="621000"/>
+            <a:ext cx="44640" cy="620640"/>
           </a:xfrm>
           <a:prstGeom prst="rect">
             <a:avLst/>
@@ -3393,6 +3439,11 @@
             <a:noAutofit/>
           </a:bodyPr>
           <a:p>
+            <a:pPr>
+              <a:lnSpc>
+                <a:spcPct val="100000"/>
+              </a:lnSpc>
+            </a:pPr>
             <a:endParaRPr b="0" lang="pt-PT" sz="1800" spc="-1" strike="noStrike">
               <a:solidFill>
                 <a:srgbClr val="ffffff"/>
@@ -3411,7 +3462,7 @@
         <p:spPr>
           <a:xfrm>
             <a:off x="6364080" y="1005840"/>
-            <a:ext cx="2559600" cy="255240"/>
+            <a:ext cx="2559240" cy="254880"/>
           </a:xfrm>
           <a:prstGeom prst="rect">
             <a:avLst/>
@@ -3468,7 +3519,7 @@
         <p:spPr>
           <a:xfrm>
             <a:off x="6364080" y="1280160"/>
-            <a:ext cx="2559600" cy="273600"/>
+            <a:ext cx="2559240" cy="273240"/>
           </a:xfrm>
           <a:prstGeom prst="rect">
             <a:avLst/>
@@ -3525,7 +3576,7 @@
         <p:spPr>
           <a:xfrm>
             <a:off x="360000" y="1800000"/>
-            <a:ext cx="8640000" cy="2871000"/>
+            <a:ext cx="8639640" cy="2870640"/>
           </a:xfrm>
           <a:prstGeom prst="rect">
             <a:avLst/>
@@ -3551,6 +3602,11 @@
             <a:noAutofit/>
           </a:bodyPr>
           <a:p>
+            <a:pPr>
+              <a:lnSpc>
+                <a:spcPct val="100000"/>
+              </a:lnSpc>
+            </a:pPr>
             <a:endParaRPr b="0" lang="pt-PT" sz="1800" spc="-1" strike="noStrike">
               <a:solidFill>
                 <a:srgbClr val="ffffff"/>
@@ -3569,7 +3625,7 @@
         <p:spPr>
           <a:xfrm>
             <a:off x="365760" y="4736880"/>
-            <a:ext cx="8411760" cy="163800"/>
+            <a:ext cx="8411400" cy="163440"/>
           </a:xfrm>
           <a:prstGeom prst="rect">
             <a:avLst/>
@@ -3630,7 +3686,7 @@
         <p:spPr>
           <a:xfrm>
             <a:off x="1296000" y="1872000"/>
-            <a:ext cx="6444000" cy="2700000"/>
+            <a:ext cx="6443640" cy="2699640"/>
           </a:xfrm>
           <a:prstGeom prst="rect">
             <a:avLst/>
@@ -3686,7 +3742,7 @@
         <p:spPr>
           <a:xfrm>
             <a:off x="411480" y="255960"/>
-            <a:ext cx="63720" cy="502560"/>
+            <a:ext cx="63360" cy="502200"/>
           </a:xfrm>
           <a:prstGeom prst="rect">
             <a:avLst/>
@@ -3712,6 +3768,11 @@
             <a:noAutofit/>
           </a:bodyPr>
           <a:p>
+            <a:pPr>
+              <a:lnSpc>
+                <a:spcPct val="100000"/>
+              </a:lnSpc>
+            </a:pPr>
             <a:endParaRPr b="0" lang="pt-PT" sz="1800" spc="-1" strike="noStrike">
               <a:solidFill>
                 <a:srgbClr val="ffffff"/>
@@ -3730,7 +3791,7 @@
         <p:spPr>
           <a:xfrm>
             <a:off x="548640" y="201240"/>
-            <a:ext cx="5486040" cy="594000"/>
+            <a:ext cx="5485680" cy="593640"/>
           </a:xfrm>
           <a:prstGeom prst="rect">
             <a:avLst/>
@@ -3787,7 +3848,7 @@
         <p:spPr>
           <a:xfrm>
             <a:off x="548640" y="4846680"/>
-            <a:ext cx="8046360" cy="228240"/>
+            <a:ext cx="8046000" cy="227880"/>
           </a:xfrm>
           <a:prstGeom prst="rect">
             <a:avLst/>
@@ -3844,7 +3905,7 @@
         <p:spPr>
           <a:xfrm>
             <a:off x="411480" y="960120"/>
-            <a:ext cx="4388760" cy="658080"/>
+            <a:ext cx="4388400" cy="657720"/>
           </a:xfrm>
           <a:prstGeom prst="rect">
             <a:avLst/>
@@ -3870,6 +3931,11 @@
             <a:noAutofit/>
           </a:bodyPr>
           <a:p>
+            <a:pPr>
+              <a:lnSpc>
+                <a:spcPct val="100000"/>
+              </a:lnSpc>
+            </a:pPr>
             <a:endParaRPr b="0" lang="pt-PT" sz="1800" spc="-1" strike="noStrike">
               <a:solidFill>
                 <a:srgbClr val="ffffff"/>
@@ -3888,7 +3954,7 @@
         <p:spPr>
           <a:xfrm>
             <a:off x="576000" y="1014840"/>
-            <a:ext cx="4114440" cy="255600"/>
+            <a:ext cx="4114080" cy="255240"/>
           </a:xfrm>
           <a:prstGeom prst="rect">
             <a:avLst/>
@@ -3945,7 +4011,7 @@
         <p:spPr>
           <a:xfrm>
             <a:off x="576000" y="1280160"/>
-            <a:ext cx="4114440" cy="255600"/>
+            <a:ext cx="4114080" cy="255240"/>
           </a:xfrm>
           <a:prstGeom prst="rect">
             <a:avLst/>
@@ -3982,367 +4048,7 @@
                 <a:latin typeface="Calibri"/>
                 <a:ea typeface="Calibri"/>
               </a:rPr>
-              <a:t>H</a:t>
-            </a:r>
-            <a:r>
-              <a:rPr b="0" lang="en-US" sz="1000" spc="-1" strike="noStrike">
-                <a:solidFill>
-                  <a:srgbClr val="8a8a9a"/>
-                </a:solidFill>
-                <a:latin typeface="Calibri"/>
-                <a:ea typeface="Calibri"/>
-              </a:rPr>
-              <a:t>T</a:t>
-            </a:r>
-            <a:r>
-              <a:rPr b="0" lang="en-US" sz="1000" spc="-1" strike="noStrike">
-                <a:solidFill>
-                  <a:srgbClr val="8a8a9a"/>
-                </a:solidFill>
-                <a:latin typeface="Calibri"/>
-                <a:ea typeface="Calibri"/>
-              </a:rPr>
-              <a:t>T</a:t>
-            </a:r>
-            <a:r>
-              <a:rPr b="0" lang="en-US" sz="1000" spc="-1" strike="noStrike">
-                <a:solidFill>
-                  <a:srgbClr val="8a8a9a"/>
-                </a:solidFill>
-                <a:latin typeface="Calibri"/>
-                <a:ea typeface="Calibri"/>
-              </a:rPr>
-              <a:t>P</a:t>
-            </a:r>
-            <a:r>
-              <a:rPr b="0" lang="en-US" sz="1000" spc="-1" strike="noStrike">
-                <a:solidFill>
-                  <a:srgbClr val="8a8a9a"/>
-                </a:solidFill>
-                <a:latin typeface="Calibri"/>
-                <a:ea typeface="Calibri"/>
-              </a:rPr>
-              <a:t> </a:t>
-            </a:r>
-            <a:r>
-              <a:rPr b="0" lang="en-US" sz="1000" spc="-1" strike="noStrike">
-                <a:solidFill>
-                  <a:srgbClr val="8a8a9a"/>
-                </a:solidFill>
-                <a:latin typeface="Calibri"/>
-                <a:ea typeface="Calibri"/>
-              </a:rPr>
-              <a:t>e</a:t>
-            </a:r>
-            <a:r>
-              <a:rPr b="0" lang="en-US" sz="1000" spc="-1" strike="noStrike">
-                <a:solidFill>
-                  <a:srgbClr val="8a8a9a"/>
-                </a:solidFill>
-                <a:latin typeface="Calibri"/>
-                <a:ea typeface="Calibri"/>
-              </a:rPr>
-              <a:t>n</a:t>
-            </a:r>
-            <a:r>
-              <a:rPr b="0" lang="en-US" sz="1000" spc="-1" strike="noStrike">
-                <a:solidFill>
-                  <a:srgbClr val="8a8a9a"/>
-                </a:solidFill>
-                <a:latin typeface="Calibri"/>
-                <a:ea typeface="Calibri"/>
-              </a:rPr>
-              <a:t>t</a:t>
-            </a:r>
-            <a:r>
-              <a:rPr b="0" lang="en-US" sz="1000" spc="-1" strike="noStrike">
-                <a:solidFill>
-                  <a:srgbClr val="8a8a9a"/>
-                </a:solidFill>
-                <a:latin typeface="Calibri"/>
-                <a:ea typeface="Calibri"/>
-              </a:rPr>
-              <a:t>r</a:t>
-            </a:r>
-            <a:r>
-              <a:rPr b="0" lang="en-US" sz="1000" spc="-1" strike="noStrike">
-                <a:solidFill>
-                  <a:srgbClr val="8a8a9a"/>
-                </a:solidFill>
-                <a:latin typeface="Calibri"/>
-                <a:ea typeface="Calibri"/>
-              </a:rPr>
-              <a:t>y</a:t>
-            </a:r>
-            <a:r>
-              <a:rPr b="0" lang="en-US" sz="1000" spc="-1" strike="noStrike">
-                <a:solidFill>
-                  <a:srgbClr val="8a8a9a"/>
-                </a:solidFill>
-                <a:latin typeface="Calibri"/>
-                <a:ea typeface="Calibri"/>
-              </a:rPr>
-              <a:t> </a:t>
-            </a:r>
-            <a:r>
-              <a:rPr b="0" lang="en-US" sz="1000" spc="-1" strike="noStrike">
-                <a:solidFill>
-                  <a:srgbClr val="8a8a9a"/>
-                </a:solidFill>
-                <a:latin typeface="Calibri"/>
-                <a:ea typeface="Calibri"/>
-              </a:rPr>
-              <a:t>p</a:t>
-            </a:r>
-            <a:r>
-              <a:rPr b="0" lang="en-US" sz="1000" spc="-1" strike="noStrike">
-                <a:solidFill>
-                  <a:srgbClr val="8a8a9a"/>
-                </a:solidFill>
-                <a:latin typeface="Calibri"/>
-                <a:ea typeface="Calibri"/>
-              </a:rPr>
-              <a:t>o</a:t>
-            </a:r>
-            <a:r>
-              <a:rPr b="0" lang="en-US" sz="1000" spc="-1" strike="noStrike">
-                <a:solidFill>
-                  <a:srgbClr val="8a8a9a"/>
-                </a:solidFill>
-                <a:latin typeface="Calibri"/>
-                <a:ea typeface="Calibri"/>
-              </a:rPr>
-              <a:t>i</a:t>
-            </a:r>
-            <a:r>
-              <a:rPr b="0" lang="en-US" sz="1000" spc="-1" strike="noStrike">
-                <a:solidFill>
-                  <a:srgbClr val="8a8a9a"/>
-                </a:solidFill>
-                <a:latin typeface="Calibri"/>
-                <a:ea typeface="Calibri"/>
-              </a:rPr>
-              <a:t>n</a:t>
-            </a:r>
-            <a:r>
-              <a:rPr b="0" lang="en-US" sz="1000" spc="-1" strike="noStrike">
-                <a:solidFill>
-                  <a:srgbClr val="8a8a9a"/>
-                </a:solidFill>
-                <a:latin typeface="Calibri"/>
-                <a:ea typeface="Calibri"/>
-              </a:rPr>
-              <a:t>t</a:t>
-            </a:r>
-            <a:r>
-              <a:rPr b="0" lang="en-US" sz="1000" spc="-1" strike="noStrike">
-                <a:solidFill>
-                  <a:srgbClr val="8a8a9a"/>
-                </a:solidFill>
-                <a:latin typeface="Calibri"/>
-                <a:ea typeface="Calibri"/>
-              </a:rPr>
-              <a:t> </a:t>
-            </a:r>
-            <a:r>
-              <a:rPr b="0" lang="en-US" sz="1000" spc="-1" strike="noStrike">
-                <a:solidFill>
-                  <a:srgbClr val="8a8a9a"/>
-                </a:solidFill>
-                <a:latin typeface="Calibri"/>
-                <a:ea typeface="Calibri"/>
-              </a:rPr>
-              <a:t>—</a:t>
-            </a:r>
-            <a:r>
-              <a:rPr b="0" lang="en-US" sz="1000" spc="-1" strike="noStrike">
-                <a:solidFill>
-                  <a:srgbClr val="8a8a9a"/>
-                </a:solidFill>
-                <a:latin typeface="Calibri"/>
-                <a:ea typeface="Calibri"/>
-              </a:rPr>
-              <a:t> </a:t>
-            </a:r>
-            <a:r>
-              <a:rPr b="0" lang="en-US" sz="1000" spc="-1" strike="noStrike">
-                <a:solidFill>
-                  <a:srgbClr val="8a8a9a"/>
-                </a:solidFill>
-                <a:latin typeface="Calibri"/>
-                <a:ea typeface="Calibri"/>
-              </a:rPr>
-              <a:t>C</a:t>
-            </a:r>
-            <a:r>
-              <a:rPr b="0" lang="en-US" sz="1000" spc="-1" strike="noStrike">
-                <a:solidFill>
-                  <a:srgbClr val="8a8a9a"/>
-                </a:solidFill>
-                <a:latin typeface="Calibri"/>
-                <a:ea typeface="Calibri"/>
-              </a:rPr>
-              <a:t>o</a:t>
-            </a:r>
-            <a:r>
-              <a:rPr b="0" lang="en-US" sz="1000" spc="-1" strike="noStrike">
-                <a:solidFill>
-                  <a:srgbClr val="8a8a9a"/>
-                </a:solidFill>
-                <a:latin typeface="Calibri"/>
-                <a:ea typeface="Calibri"/>
-              </a:rPr>
-              <a:t>n</a:t>
-            </a:r>
-            <a:r>
-              <a:rPr b="0" lang="en-US" sz="1000" spc="-1" strike="noStrike">
-                <a:solidFill>
-                  <a:srgbClr val="8a8a9a"/>
-                </a:solidFill>
-                <a:latin typeface="Calibri"/>
-                <a:ea typeface="Calibri"/>
-              </a:rPr>
-              <a:t>t</a:t>
-            </a:r>
-            <a:r>
-              <a:rPr b="0" lang="en-US" sz="1000" spc="-1" strike="noStrike">
-                <a:solidFill>
-                  <a:srgbClr val="8a8a9a"/>
-                </a:solidFill>
-                <a:latin typeface="Calibri"/>
-                <a:ea typeface="Calibri"/>
-              </a:rPr>
-              <a:t>r</a:t>
-            </a:r>
-            <a:r>
-              <a:rPr b="0" lang="en-US" sz="1000" spc="-1" strike="noStrike">
-                <a:solidFill>
-                  <a:srgbClr val="8a8a9a"/>
-                </a:solidFill>
-                <a:latin typeface="Calibri"/>
-                <a:ea typeface="Calibri"/>
-              </a:rPr>
-              <a:t>o</a:t>
-            </a:r>
-            <a:r>
-              <a:rPr b="0" lang="en-US" sz="1000" spc="-1" strike="noStrike">
-                <a:solidFill>
-                  <a:srgbClr val="8a8a9a"/>
-                </a:solidFill>
-                <a:latin typeface="Calibri"/>
-                <a:ea typeface="Calibri"/>
-              </a:rPr>
-              <a:t>l</a:t>
-            </a:r>
-            <a:r>
-              <a:rPr b="0" lang="en-US" sz="1000" spc="-1" strike="noStrike">
-                <a:solidFill>
-                  <a:srgbClr val="8a8a9a"/>
-                </a:solidFill>
-                <a:latin typeface="Calibri"/>
-                <a:ea typeface="Calibri"/>
-              </a:rPr>
-              <a:t>l</a:t>
-            </a:r>
-            <a:r>
-              <a:rPr b="0" lang="en-US" sz="1000" spc="-1" strike="noStrike">
-                <a:solidFill>
-                  <a:srgbClr val="8a8a9a"/>
-                </a:solidFill>
-                <a:latin typeface="Calibri"/>
-                <a:ea typeface="Calibri"/>
-              </a:rPr>
-              <a:t>e</a:t>
-            </a:r>
-            <a:r>
-              <a:rPr b="0" lang="en-US" sz="1000" spc="-1" strike="noStrike">
-                <a:solidFill>
-                  <a:srgbClr val="8a8a9a"/>
-                </a:solidFill>
-                <a:latin typeface="Calibri"/>
-                <a:ea typeface="Calibri"/>
-              </a:rPr>
-              <a:t>r</a:t>
-            </a:r>
-            <a:r>
-              <a:rPr b="0" lang="en-US" sz="1000" spc="-1" strike="noStrike">
-                <a:solidFill>
-                  <a:srgbClr val="8a8a9a"/>
-                </a:solidFill>
-                <a:latin typeface="Calibri"/>
-                <a:ea typeface="Calibri"/>
-              </a:rPr>
-              <a:t>s</a:t>
-            </a:r>
-            <a:r>
-              <a:rPr b="0" lang="en-US" sz="1000" spc="-1" strike="noStrike">
-                <a:solidFill>
-                  <a:srgbClr val="8a8a9a"/>
-                </a:solidFill>
-                <a:latin typeface="Calibri"/>
-                <a:ea typeface="Calibri"/>
-              </a:rPr>
-              <a:t>,</a:t>
-            </a:r>
-            <a:r>
-              <a:rPr b="0" lang="en-US" sz="1000" spc="-1" strike="noStrike">
-                <a:solidFill>
-                  <a:srgbClr val="8a8a9a"/>
-                </a:solidFill>
-                <a:latin typeface="Calibri"/>
-                <a:ea typeface="Calibri"/>
-              </a:rPr>
-              <a:t> </a:t>
-            </a:r>
-            <a:r>
-              <a:rPr b="0" lang="en-US" sz="1000" spc="-1" strike="noStrike">
-                <a:solidFill>
-                  <a:srgbClr val="8a8a9a"/>
-                </a:solidFill>
-                <a:latin typeface="Calibri"/>
-                <a:ea typeface="Calibri"/>
-              </a:rPr>
-              <a:t>V</a:t>
-            </a:r>
-            <a:r>
-              <a:rPr b="0" lang="en-US" sz="1000" spc="-1" strike="noStrike">
-                <a:solidFill>
-                  <a:srgbClr val="8a8a9a"/>
-                </a:solidFill>
-                <a:latin typeface="Calibri"/>
-                <a:ea typeface="Calibri"/>
-              </a:rPr>
-              <a:t>i</a:t>
-            </a:r>
-            <a:r>
-              <a:rPr b="0" lang="en-US" sz="1000" spc="-1" strike="noStrike">
-                <a:solidFill>
-                  <a:srgbClr val="8a8a9a"/>
-                </a:solidFill>
-                <a:latin typeface="Calibri"/>
-                <a:ea typeface="Calibri"/>
-              </a:rPr>
-              <a:t>e</a:t>
-            </a:r>
-            <a:r>
-              <a:rPr b="0" lang="en-US" sz="1000" spc="-1" strike="noStrike">
-                <a:solidFill>
-                  <a:srgbClr val="8a8a9a"/>
-                </a:solidFill>
-                <a:latin typeface="Calibri"/>
-                <a:ea typeface="Calibri"/>
-              </a:rPr>
-              <a:t>w</a:t>
-            </a:r>
-            <a:r>
-              <a:rPr b="0" lang="en-US" sz="1000" spc="-1" strike="noStrike">
-                <a:solidFill>
-                  <a:srgbClr val="8a8a9a"/>
-                </a:solidFill>
-                <a:latin typeface="Calibri"/>
-                <a:ea typeface="Calibri"/>
-              </a:rPr>
-              <a:t>s</a:t>
+              <a:t>HTTP entry point — Controllers, Views</a:t>
             </a:r>
             <a:endParaRPr b="0" lang="pt-PT" sz="1000" spc="-1" strike="noStrike">
               <a:solidFill>
@@ -4403,7 +4109,7 @@
         <p:spPr>
           <a:xfrm>
             <a:off x="411480" y="1691640"/>
-            <a:ext cx="4388760" cy="658080"/>
+            <a:ext cx="4388400" cy="657720"/>
           </a:xfrm>
           <a:prstGeom prst="rect">
             <a:avLst/>
@@ -4429,6 +4135,11 @@
             <a:noAutofit/>
           </a:bodyPr>
           <a:p>
+            <a:pPr>
+              <a:lnSpc>
+                <a:spcPct val="100000"/>
+              </a:lnSpc>
+            </a:pPr>
             <a:endParaRPr b="0" lang="pt-PT" sz="1800" spc="-1" strike="noStrike">
               <a:solidFill>
                 <a:srgbClr val="ffffff"/>
@@ -4447,7 +4158,7 @@
         <p:spPr>
           <a:xfrm>
             <a:off x="576000" y="1746360"/>
-            <a:ext cx="4114440" cy="255600"/>
+            <a:ext cx="4114080" cy="255240"/>
           </a:xfrm>
           <a:prstGeom prst="rect">
             <a:avLst/>
@@ -4504,7 +4215,7 @@
         <p:spPr>
           <a:xfrm>
             <a:off x="576000" y="2011680"/>
-            <a:ext cx="4114440" cy="255600"/>
+            <a:ext cx="4114080" cy="255240"/>
           </a:xfrm>
           <a:prstGeom prst="rect">
             <a:avLst/>
@@ -4602,7 +4313,7 @@
         <p:spPr>
           <a:xfrm>
             <a:off x="411480" y="2423160"/>
-            <a:ext cx="4388760" cy="658080"/>
+            <a:ext cx="4388400" cy="657720"/>
           </a:xfrm>
           <a:prstGeom prst="rect">
             <a:avLst/>
@@ -4628,6 +4339,11 @@
             <a:noAutofit/>
           </a:bodyPr>
           <a:p>
+            <a:pPr>
+              <a:lnSpc>
+                <a:spcPct val="100000"/>
+              </a:lnSpc>
+            </a:pPr>
             <a:endParaRPr b="0" lang="pt-PT" sz="1800" spc="-1" strike="noStrike">
               <a:solidFill>
                 <a:srgbClr val="ffffff"/>
@@ -4646,7 +4362,7 @@
         <p:spPr>
           <a:xfrm>
             <a:off x="576000" y="2477880"/>
-            <a:ext cx="4114440" cy="255600"/>
+            <a:ext cx="4114080" cy="255240"/>
           </a:xfrm>
           <a:prstGeom prst="rect">
             <a:avLst/>
@@ -4703,7 +4419,7 @@
         <p:spPr>
           <a:xfrm>
             <a:off x="576000" y="2743560"/>
-            <a:ext cx="4114440" cy="255600"/>
+            <a:ext cx="4114080" cy="255240"/>
           </a:xfrm>
           <a:prstGeom prst="rect">
             <a:avLst/>
@@ -4801,7 +4517,7 @@
         <p:spPr>
           <a:xfrm>
             <a:off x="411480" y="3155040"/>
-            <a:ext cx="4388760" cy="658080"/>
+            <a:ext cx="4388400" cy="657720"/>
           </a:xfrm>
           <a:prstGeom prst="rect">
             <a:avLst/>
@@ -4827,6 +4543,11 @@
             <a:noAutofit/>
           </a:bodyPr>
           <a:p>
+            <a:pPr>
+              <a:lnSpc>
+                <a:spcPct val="100000"/>
+              </a:lnSpc>
+            </a:pPr>
             <a:endParaRPr b="0" lang="pt-PT" sz="1800" spc="-1" strike="noStrike">
               <a:solidFill>
                 <a:srgbClr val="ffffff"/>
@@ -4845,7 +4566,7 @@
         <p:spPr>
           <a:xfrm>
             <a:off x="576000" y="3209760"/>
-            <a:ext cx="4114440" cy="255600"/>
+            <a:ext cx="4114080" cy="255240"/>
           </a:xfrm>
           <a:prstGeom prst="rect">
             <a:avLst/>
@@ -4882,77 +4603,7 @@
                 <a:latin typeface="Consolas"/>
                 <a:ea typeface="Consolas"/>
               </a:rPr>
-              <a:t>N</a:t>
-            </a:r>
-            <a:r>
-              <a:rPr b="1" lang="en-US" sz="1300" spc="-1" strike="noStrike">
-                <a:solidFill>
-                  <a:srgbClr val="c8c8d8"/>
-                </a:solidFill>
-                <a:latin typeface="Consolas"/>
-                <a:ea typeface="Consolas"/>
-              </a:rPr>
-              <a:t>o</a:t>
-            </a:r>
-            <a:r>
-              <a:rPr b="1" lang="en-US" sz="1300" spc="-1" strike="noStrike">
-                <a:solidFill>
-                  <a:srgbClr val="c8c8d8"/>
-                </a:solidFill>
-                <a:latin typeface="Consolas"/>
-                <a:ea typeface="Consolas"/>
-              </a:rPr>
-              <a:t>p</a:t>
-            </a:r>
-            <a:r>
-              <a:rPr b="1" lang="en-US" sz="1300" spc="-1" strike="noStrike">
-                <a:solidFill>
-                  <a:srgbClr val="c8c8d8"/>
-                </a:solidFill>
-                <a:latin typeface="Consolas"/>
-                <a:ea typeface="Consolas"/>
-              </a:rPr>
-              <a:t>.</a:t>
-            </a:r>
-            <a:r>
-              <a:rPr b="1" lang="en-US" sz="1300" spc="-1" strike="noStrike">
-                <a:solidFill>
-                  <a:srgbClr val="c8c8d8"/>
-                </a:solidFill>
-                <a:latin typeface="Consolas"/>
-                <a:ea typeface="Consolas"/>
-              </a:rPr>
-              <a:t>D</a:t>
-            </a:r>
-            <a:r>
-              <a:rPr b="1" lang="en-US" sz="1300" spc="-1" strike="noStrike">
-                <a:solidFill>
-                  <a:srgbClr val="c8c8d8"/>
-                </a:solidFill>
-                <a:latin typeface="Consolas"/>
-                <a:ea typeface="Consolas"/>
-              </a:rPr>
-              <a:t>a</a:t>
-            </a:r>
-            <a:r>
-              <a:rPr b="1" lang="en-US" sz="1300" spc="-1" strike="noStrike">
-                <a:solidFill>
-                  <a:srgbClr val="c8c8d8"/>
-                </a:solidFill>
-                <a:latin typeface="Consolas"/>
-                <a:ea typeface="Consolas"/>
-              </a:rPr>
-              <a:t>t</a:t>
-            </a:r>
-            <a:r>
-              <a:rPr b="1" lang="en-US" sz="1300" spc="-1" strike="noStrike">
-                <a:solidFill>
-                  <a:srgbClr val="c8c8d8"/>
-                </a:solidFill>
-                <a:latin typeface="Consolas"/>
-                <a:ea typeface="Consolas"/>
-              </a:rPr>
-              <a:t>a</a:t>
+              <a:t>Nop.Data</a:t>
             </a:r>
             <a:endParaRPr b="0" lang="pt-PT" sz="1300" spc="-1" strike="noStrike">
               <a:solidFill>
@@ -4972,7 +4623,7 @@
         <p:spPr>
           <a:xfrm>
             <a:off x="576000" y="3475080"/>
-            <a:ext cx="4114440" cy="255600"/>
+            <a:ext cx="4114080" cy="255240"/>
           </a:xfrm>
           <a:prstGeom prst="rect">
             <a:avLst/>
@@ -5070,7 +4721,7 @@
         <p:spPr>
           <a:xfrm>
             <a:off x="411480" y="3886560"/>
-            <a:ext cx="4388760" cy="658080"/>
+            <a:ext cx="4388400" cy="657720"/>
           </a:xfrm>
           <a:prstGeom prst="rect">
             <a:avLst/>
@@ -5096,6 +4747,11 @@
             <a:noAutofit/>
           </a:bodyPr>
           <a:p>
+            <a:pPr>
+              <a:lnSpc>
+                <a:spcPct val="100000"/>
+              </a:lnSpc>
+            </a:pPr>
             <a:endParaRPr b="0" lang="pt-PT" sz="1800" spc="-1" strike="noStrike">
               <a:solidFill>
                 <a:srgbClr val="ffffff"/>
@@ -5114,7 +4770,7 @@
         <p:spPr>
           <a:xfrm>
             <a:off x="576000" y="3941280"/>
-            <a:ext cx="4114440" cy="255600"/>
+            <a:ext cx="4114080" cy="255240"/>
           </a:xfrm>
           <a:prstGeom prst="rect">
             <a:avLst/>
@@ -5171,7 +4827,7 @@
         <p:spPr>
           <a:xfrm>
             <a:off x="576000" y="4206600"/>
-            <a:ext cx="4114440" cy="255600"/>
+            <a:ext cx="4114080" cy="255240"/>
           </a:xfrm>
           <a:prstGeom prst="rect">
             <a:avLst/>
@@ -5228,7 +4884,7 @@
         <p:spPr>
           <a:xfrm>
             <a:off x="411480" y="4663800"/>
-            <a:ext cx="4388760" cy="273960"/>
+            <a:ext cx="4388400" cy="273600"/>
           </a:xfrm>
           <a:prstGeom prst="rect">
             <a:avLst/>
@@ -5275,7 +4931,7 @@
         <p:spPr>
           <a:xfrm>
             <a:off x="5166360" y="960120"/>
-            <a:ext cx="3748680" cy="3932280"/>
+            <a:ext cx="3748320" cy="3931920"/>
           </a:xfrm>
           <a:prstGeom prst="rect">
             <a:avLst/>
@@ -5301,6 +4957,11 @@
             <a:noAutofit/>
           </a:bodyPr>
           <a:p>
+            <a:pPr>
+              <a:lnSpc>
+                <a:spcPct val="100000"/>
+              </a:lnSpc>
+            </a:pPr>
             <a:endParaRPr b="0" lang="pt-PT" sz="1800" spc="-1" strike="noStrike">
               <a:solidFill>
                 <a:srgbClr val="ffffff"/>
@@ -5319,7 +4980,7 @@
         <p:spPr>
           <a:xfrm>
             <a:off x="5349240" y="1051560"/>
-            <a:ext cx="3382920" cy="319680"/>
+            <a:ext cx="3382560" cy="319320"/>
           </a:xfrm>
           <a:prstGeom prst="rect">
             <a:avLst/>
@@ -5417,7 +5078,7 @@
         <p:spPr>
           <a:xfrm>
             <a:off x="5303520" y="1508760"/>
-            <a:ext cx="3474360" cy="475200"/>
+            <a:ext cx="3474000" cy="474840"/>
           </a:xfrm>
           <a:prstGeom prst="rect">
             <a:avLst/>
@@ -5443,6 +5104,11 @@
             <a:noAutofit/>
           </a:bodyPr>
           <a:p>
+            <a:pPr>
+              <a:lnSpc>
+                <a:spcPct val="100000"/>
+              </a:lnSpc>
+            </a:pPr>
             <a:endParaRPr b="0" lang="pt-PT" sz="1800" spc="-1" strike="noStrike">
               <a:solidFill>
                 <a:srgbClr val="ffffff"/>
@@ -5461,7 +5127,7 @@
         <p:spPr>
           <a:xfrm>
             <a:off x="5367600" y="1563480"/>
-            <a:ext cx="3346200" cy="365400"/>
+            <a:ext cx="3345840" cy="365040"/>
           </a:xfrm>
           <a:prstGeom prst="rect">
             <a:avLst/>
@@ -5528,7 +5194,7 @@
         <p:spPr>
           <a:xfrm>
             <a:off x="5303520" y="2075760"/>
-            <a:ext cx="3474360" cy="475200"/>
+            <a:ext cx="3474000" cy="474840"/>
           </a:xfrm>
           <a:prstGeom prst="rect">
             <a:avLst/>
@@ -5554,6 +5220,11 @@
             <a:noAutofit/>
           </a:bodyPr>
           <a:p>
+            <a:pPr>
+              <a:lnSpc>
+                <a:spcPct val="100000"/>
+              </a:lnSpc>
+            </a:pPr>
             <a:endParaRPr b="0" lang="pt-PT" sz="1800" spc="-1" strike="noStrike">
               <a:solidFill>
                 <a:srgbClr val="ffffff"/>
@@ -5572,7 +5243,7 @@
         <p:spPr>
           <a:xfrm>
             <a:off x="5367600" y="2130480"/>
-            <a:ext cx="3346200" cy="365400"/>
+            <a:ext cx="3345840" cy="365040"/>
           </a:xfrm>
           <a:prstGeom prst="rect">
             <a:avLst/>
@@ -5639,7 +5310,7 @@
         <p:spPr>
           <a:xfrm>
             <a:off x="5303520" y="2643120"/>
-            <a:ext cx="3474360" cy="475200"/>
+            <a:ext cx="3474000" cy="474840"/>
           </a:xfrm>
           <a:prstGeom prst="rect">
             <a:avLst/>
@@ -5665,6 +5336,11 @@
             <a:noAutofit/>
           </a:bodyPr>
           <a:p>
+            <a:pPr>
+              <a:lnSpc>
+                <a:spcPct val="100000"/>
+              </a:lnSpc>
+            </a:pPr>
             <a:endParaRPr b="0" lang="pt-PT" sz="1800" spc="-1" strike="noStrike">
               <a:solidFill>
                 <a:srgbClr val="ffffff"/>
@@ -5683,7 +5359,7 @@
         <p:spPr>
           <a:xfrm>
             <a:off x="5367600" y="2697840"/>
-            <a:ext cx="3346200" cy="365400"/>
+            <a:ext cx="3345840" cy="365040"/>
           </a:xfrm>
           <a:prstGeom prst="rect">
             <a:avLst/>
@@ -5750,7 +5426,7 @@
         <p:spPr>
           <a:xfrm>
             <a:off x="5303520" y="3209760"/>
-            <a:ext cx="3474360" cy="475200"/>
+            <a:ext cx="3474000" cy="474840"/>
           </a:xfrm>
           <a:prstGeom prst="rect">
             <a:avLst/>
@@ -5776,6 +5452,11 @@
             <a:noAutofit/>
           </a:bodyPr>
           <a:p>
+            <a:pPr>
+              <a:lnSpc>
+                <a:spcPct val="100000"/>
+              </a:lnSpc>
+            </a:pPr>
             <a:endParaRPr b="0" lang="pt-PT" sz="1800" spc="-1" strike="noStrike">
               <a:solidFill>
                 <a:srgbClr val="ffffff"/>
@@ -5794,7 +5475,7 @@
         <p:spPr>
           <a:xfrm>
             <a:off x="5367600" y="3264840"/>
-            <a:ext cx="3346200" cy="365400"/>
+            <a:ext cx="3345840" cy="365040"/>
           </a:xfrm>
           <a:prstGeom prst="rect">
             <a:avLst/>
@@ -5861,7 +5542,7 @@
         <p:spPr>
           <a:xfrm>
             <a:off x="5303520" y="3776760"/>
-            <a:ext cx="3474360" cy="475200"/>
+            <a:ext cx="3474000" cy="474840"/>
           </a:xfrm>
           <a:prstGeom prst="rect">
             <a:avLst/>
@@ -5887,6 +5568,11 @@
             <a:noAutofit/>
           </a:bodyPr>
           <a:p>
+            <a:pPr>
+              <a:lnSpc>
+                <a:spcPct val="100000"/>
+              </a:lnSpc>
+            </a:pPr>
             <a:endParaRPr b="0" lang="pt-PT" sz="1800" spc="-1" strike="noStrike">
               <a:solidFill>
                 <a:srgbClr val="ffffff"/>
@@ -5905,7 +5591,7 @@
         <p:spPr>
           <a:xfrm>
             <a:off x="5367600" y="3831840"/>
-            <a:ext cx="3346200" cy="365400"/>
+            <a:ext cx="3345840" cy="365040"/>
           </a:xfrm>
           <a:prstGeom prst="rect">
             <a:avLst/>
@@ -6009,7 +5695,7 @@
         <p:spPr>
           <a:xfrm>
             <a:off x="365760" y="274320"/>
-            <a:ext cx="45000" cy="529560"/>
+            <a:ext cx="44640" cy="529200"/>
           </a:xfrm>
           <a:prstGeom prst="rect">
             <a:avLst/>
@@ -6058,7 +5744,7 @@
         <p:spPr>
           <a:xfrm>
             <a:off x="502920" y="255960"/>
-            <a:ext cx="8320320" cy="593640"/>
+            <a:ext cx="8319960" cy="593280"/>
           </a:xfrm>
           <a:prstGeom prst="rect">
             <a:avLst/>
@@ -6115,7 +5801,7 @@
         <p:spPr>
           <a:xfrm>
             <a:off x="365760" y="877680"/>
-            <a:ext cx="8411760" cy="19440"/>
+            <a:ext cx="8411400" cy="19080"/>
           </a:xfrm>
           <a:prstGeom prst="rect">
             <a:avLst/>
@@ -6164,7 +5850,7 @@
         <p:spPr>
           <a:xfrm>
             <a:off x="0" y="4906080"/>
-            <a:ext cx="9143280" cy="236880"/>
+            <a:ext cx="9142920" cy="236520"/>
           </a:xfrm>
           <a:prstGeom prst="rect">
             <a:avLst/>
@@ -6213,7 +5899,7 @@
         <p:spPr>
           <a:xfrm>
             <a:off x="365760" y="4906080"/>
-            <a:ext cx="8411760" cy="236880"/>
+            <a:ext cx="8411400" cy="236520"/>
           </a:xfrm>
           <a:prstGeom prst="rect">
             <a:avLst/>
@@ -6270,7 +5956,7 @@
         <p:spPr>
           <a:xfrm>
             <a:off x="365760" y="1005840"/>
-            <a:ext cx="1782360" cy="419760"/>
+            <a:ext cx="1782000" cy="419400"/>
           </a:xfrm>
           <a:prstGeom prst="rect">
             <a:avLst/>
@@ -6319,7 +6005,7 @@
         <p:spPr>
           <a:xfrm>
             <a:off x="365760" y="1005840"/>
-            <a:ext cx="1782360" cy="419760"/>
+            <a:ext cx="1782000" cy="419400"/>
           </a:xfrm>
           <a:prstGeom prst="rect">
             <a:avLst/>
@@ -6376,7 +6062,7 @@
         <p:spPr>
           <a:xfrm>
             <a:off x="2148840" y="1195920"/>
-            <a:ext cx="127440" cy="39600"/>
+            <a:ext cx="127080" cy="39240"/>
           </a:xfrm>
           <a:prstGeom prst="rect">
             <a:avLst/>
@@ -6425,7 +6111,7 @@
         <p:spPr>
           <a:xfrm>
             <a:off x="2240280" y="1170360"/>
-            <a:ext cx="36000" cy="90720"/>
+            <a:ext cx="35640" cy="90360"/>
           </a:xfrm>
           <a:prstGeom prst="rect">
             <a:avLst/>
@@ -6474,7 +6160,7 @@
         <p:spPr>
           <a:xfrm>
             <a:off x="2277000" y="1005840"/>
-            <a:ext cx="1782360" cy="419760"/>
+            <a:ext cx="1782000" cy="419400"/>
           </a:xfrm>
           <a:prstGeom prst="rect">
             <a:avLst/>
@@ -6523,7 +6209,7 @@
         <p:spPr>
           <a:xfrm>
             <a:off x="2277000" y="1005840"/>
-            <a:ext cx="1782360" cy="419760"/>
+            <a:ext cx="1782000" cy="419400"/>
           </a:xfrm>
           <a:prstGeom prst="rect">
             <a:avLst/>
@@ -6580,7 +6266,7 @@
         <p:spPr>
           <a:xfrm>
             <a:off x="4060080" y="1195920"/>
-            <a:ext cx="127440" cy="39600"/>
+            <a:ext cx="127080" cy="39240"/>
           </a:xfrm>
           <a:prstGeom prst="rect">
             <a:avLst/>
@@ -6629,7 +6315,7 @@
         <p:spPr>
           <a:xfrm>
             <a:off x="4151520" y="1170360"/>
-            <a:ext cx="36000" cy="90720"/>
+            <a:ext cx="35640" cy="90360"/>
           </a:xfrm>
           <a:prstGeom prst="rect">
             <a:avLst/>
@@ -6678,7 +6364,7 @@
         <p:spPr>
           <a:xfrm>
             <a:off x="4187880" y="1005840"/>
-            <a:ext cx="1782360" cy="419760"/>
+            <a:ext cx="1782000" cy="419400"/>
           </a:xfrm>
           <a:prstGeom prst="rect">
             <a:avLst/>
@@ -6727,7 +6413,7 @@
         <p:spPr>
           <a:xfrm>
             <a:off x="4187880" y="1005840"/>
-            <a:ext cx="1782360" cy="419760"/>
+            <a:ext cx="1782000" cy="419400"/>
           </a:xfrm>
           <a:prstGeom prst="rect">
             <a:avLst/>
@@ -6784,7 +6470,7 @@
         <p:spPr>
           <a:xfrm>
             <a:off x="5970960" y="1195920"/>
-            <a:ext cx="127440" cy="39600"/>
+            <a:ext cx="127080" cy="39240"/>
           </a:xfrm>
           <a:prstGeom prst="rect">
             <a:avLst/>
@@ -6833,7 +6519,7 @@
         <p:spPr>
           <a:xfrm>
             <a:off x="6062400" y="1170360"/>
-            <a:ext cx="36000" cy="90720"/>
+            <a:ext cx="35640" cy="90360"/>
           </a:xfrm>
           <a:prstGeom prst="rect">
             <a:avLst/>
@@ -6882,7 +6568,7 @@
         <p:spPr>
           <a:xfrm>
             <a:off x="6099120" y="1005840"/>
-            <a:ext cx="1782360" cy="419760"/>
+            <a:ext cx="1782000" cy="419400"/>
           </a:xfrm>
           <a:prstGeom prst="rect">
             <a:avLst/>
@@ -6931,7 +6617,7 @@
         <p:spPr>
           <a:xfrm>
             <a:off x="6099120" y="1005840"/>
-            <a:ext cx="1782360" cy="419760"/>
+            <a:ext cx="1782000" cy="419400"/>
           </a:xfrm>
           <a:prstGeom prst="rect">
             <a:avLst/>
@@ -6988,7 +6674,7 @@
         <p:spPr>
           <a:xfrm>
             <a:off x="365760" y="1572840"/>
-            <a:ext cx="8411760" cy="19440"/>
+            <a:ext cx="8411400" cy="19080"/>
           </a:xfrm>
           <a:prstGeom prst="rect">
             <a:avLst/>
@@ -7037,7 +6723,7 @@
         <p:spPr>
           <a:xfrm>
             <a:off x="365760" y="1901880"/>
-            <a:ext cx="49680" cy="49680"/>
+            <a:ext cx="49320" cy="49320"/>
           </a:xfrm>
           <a:prstGeom prst="rect">
             <a:avLst/>
@@ -7086,7 +6772,7 @@
         <p:spPr>
           <a:xfrm>
             <a:off x="530280" y="1719000"/>
-            <a:ext cx="8228880" cy="694080"/>
+            <a:ext cx="8228520" cy="693720"/>
           </a:xfrm>
           <a:prstGeom prst="rect">
             <a:avLst/>
@@ -7143,7 +6829,7 @@
         <p:spPr>
           <a:xfrm>
             <a:off x="365760" y="2670480"/>
-            <a:ext cx="49680" cy="49680"/>
+            <a:ext cx="49320" cy="49320"/>
           </a:xfrm>
           <a:prstGeom prst="rect">
             <a:avLst/>
@@ -7192,7 +6878,7 @@
         <p:spPr>
           <a:xfrm>
             <a:off x="530280" y="2487240"/>
-            <a:ext cx="8228880" cy="694080"/>
+            <a:ext cx="8228520" cy="693720"/>
           </a:xfrm>
           <a:prstGeom prst="rect">
             <a:avLst/>
@@ -7249,7 +6935,7 @@
         <p:spPr>
           <a:xfrm>
             <a:off x="365760" y="3438360"/>
-            <a:ext cx="49680" cy="49680"/>
+            <a:ext cx="49320" cy="49320"/>
           </a:xfrm>
           <a:prstGeom prst="rect">
             <a:avLst/>
@@ -7298,7 +6984,7 @@
         <p:spPr>
           <a:xfrm>
             <a:off x="530280" y="3255480"/>
-            <a:ext cx="8228880" cy="694080"/>
+            <a:ext cx="8228520" cy="693720"/>
           </a:xfrm>
           <a:prstGeom prst="rect">
             <a:avLst/>
@@ -7355,7 +7041,7 @@
         <p:spPr>
           <a:xfrm>
             <a:off x="365760" y="4206600"/>
-            <a:ext cx="49680" cy="49680"/>
+            <a:ext cx="49320" cy="49320"/>
           </a:xfrm>
           <a:prstGeom prst="rect">
             <a:avLst/>
@@ -7404,7 +7090,7 @@
         <p:spPr>
           <a:xfrm>
             <a:off x="530280" y="4023720"/>
-            <a:ext cx="8228880" cy="694080"/>
+            <a:ext cx="8228520" cy="693720"/>
           </a:xfrm>
           <a:prstGeom prst="rect">
             <a:avLst/>
@@ -7498,7 +7184,7 @@
         <p:spPr>
           <a:xfrm>
             <a:off x="365760" y="274320"/>
-            <a:ext cx="45000" cy="529560"/>
+            <a:ext cx="44640" cy="529200"/>
           </a:xfrm>
           <a:prstGeom prst="rect">
             <a:avLst/>
@@ -7547,7 +7233,7 @@
         <p:spPr>
           <a:xfrm>
             <a:off x="502920" y="255960"/>
-            <a:ext cx="8320320" cy="593640"/>
+            <a:ext cx="8319960" cy="593280"/>
           </a:xfrm>
           <a:prstGeom prst="rect">
             <a:avLst/>
@@ -7604,7 +7290,7 @@
         <p:spPr>
           <a:xfrm>
             <a:off x="365760" y="877680"/>
-            <a:ext cx="8411760" cy="19440"/>
+            <a:ext cx="8411400" cy="19080"/>
           </a:xfrm>
           <a:prstGeom prst="rect">
             <a:avLst/>
@@ -7653,7 +7339,7 @@
         <p:spPr>
           <a:xfrm>
             <a:off x="0" y="4906080"/>
-            <a:ext cx="9143280" cy="236880"/>
+            <a:ext cx="9142920" cy="236520"/>
           </a:xfrm>
           <a:prstGeom prst="rect">
             <a:avLst/>
@@ -7702,7 +7388,7 @@
         <p:spPr>
           <a:xfrm>
             <a:off x="365760" y="4906080"/>
-            <a:ext cx="8411760" cy="236880"/>
+            <a:ext cx="8411400" cy="236520"/>
           </a:xfrm>
           <a:prstGeom prst="rect">
             <a:avLst/>
@@ -7759,7 +7445,7 @@
         <p:spPr>
           <a:xfrm>
             <a:off x="384120" y="996840"/>
-            <a:ext cx="6491520" cy="183600"/>
+            <a:ext cx="6491160" cy="183240"/>
           </a:xfrm>
           <a:prstGeom prst="rect">
             <a:avLst/>
@@ -7816,7 +7502,7 @@
         <p:spPr>
           <a:xfrm>
             <a:off x="6949440" y="1014840"/>
-            <a:ext cx="1828080" cy="119520"/>
+            <a:ext cx="1827720" cy="119160"/>
           </a:xfrm>
           <a:prstGeom prst="rect">
             <a:avLst/>
@@ -7865,7 +7551,7 @@
         <p:spPr>
           <a:xfrm>
             <a:off x="6949440" y="1014840"/>
-            <a:ext cx="1828080" cy="119520"/>
+            <a:ext cx="1827720" cy="119160"/>
           </a:xfrm>
           <a:prstGeom prst="rect">
             <a:avLst/>
@@ -7922,7 +7608,7 @@
         <p:spPr>
           <a:xfrm>
             <a:off x="429840" y="1305000"/>
-            <a:ext cx="145440" cy="14040"/>
+            <a:ext cx="145080" cy="13680"/>
           </a:xfrm>
           <a:prstGeom prst="rect">
             <a:avLst/>
@@ -7971,7 +7657,7 @@
         <p:spPr>
           <a:xfrm>
             <a:off x="612720" y="1226520"/>
-            <a:ext cx="6290280" cy="183600"/>
+            <a:ext cx="6289920" cy="183240"/>
           </a:xfrm>
           <a:prstGeom prst="rect">
             <a:avLst/>
@@ -8028,7 +7714,7 @@
         <p:spPr>
           <a:xfrm>
             <a:off x="6949440" y="1244880"/>
-            <a:ext cx="1828080" cy="119520"/>
+            <a:ext cx="1827720" cy="119160"/>
           </a:xfrm>
           <a:prstGeom prst="rect">
             <a:avLst/>
@@ -8077,7 +7763,7 @@
         <p:spPr>
           <a:xfrm>
             <a:off x="6949440" y="1244880"/>
-            <a:ext cx="1828080" cy="119520"/>
+            <a:ext cx="1827720" cy="119160"/>
           </a:xfrm>
           <a:prstGeom prst="rect">
             <a:avLst/>
@@ -8134,7 +7820,7 @@
         <p:spPr>
           <a:xfrm>
             <a:off x="658440" y="1534680"/>
-            <a:ext cx="145440" cy="14040"/>
+            <a:ext cx="145080" cy="13680"/>
           </a:xfrm>
           <a:prstGeom prst="rect">
             <a:avLst/>
@@ -8183,7 +7869,7 @@
         <p:spPr>
           <a:xfrm>
             <a:off x="841320" y="1456560"/>
-            <a:ext cx="6089040" cy="183600"/>
+            <a:ext cx="6088680" cy="183240"/>
           </a:xfrm>
           <a:prstGeom prst="rect">
             <a:avLst/>
@@ -8240,7 +7926,7 @@
         <p:spPr>
           <a:xfrm>
             <a:off x="6949440" y="1474920"/>
-            <a:ext cx="1828080" cy="119520"/>
+            <a:ext cx="1827720" cy="119160"/>
           </a:xfrm>
           <a:prstGeom prst="rect">
             <a:avLst/>
@@ -8289,7 +7975,7 @@
         <p:spPr>
           <a:xfrm>
             <a:off x="6949440" y="1474920"/>
-            <a:ext cx="1828080" cy="119520"/>
+            <a:ext cx="1827720" cy="119160"/>
           </a:xfrm>
           <a:prstGeom prst="rect">
             <a:avLst/>
@@ -8346,7 +8032,7 @@
         <p:spPr>
           <a:xfrm>
             <a:off x="658440" y="1764720"/>
-            <a:ext cx="145440" cy="14040"/>
+            <a:ext cx="145080" cy="13680"/>
           </a:xfrm>
           <a:prstGeom prst="rect">
             <a:avLst/>
@@ -8395,7 +8081,7 @@
         <p:spPr>
           <a:xfrm>
             <a:off x="841320" y="1686240"/>
-            <a:ext cx="6089040" cy="183600"/>
+            <a:ext cx="6088680" cy="183240"/>
           </a:xfrm>
           <a:prstGeom prst="rect">
             <a:avLst/>
@@ -8452,7 +8138,7 @@
         <p:spPr>
           <a:xfrm>
             <a:off x="6949440" y="1704600"/>
-            <a:ext cx="1828080" cy="119520"/>
+            <a:ext cx="1827720" cy="119160"/>
           </a:xfrm>
           <a:prstGeom prst="rect">
             <a:avLst/>
@@ -8501,7 +8187,7 @@
         <p:spPr>
           <a:xfrm>
             <a:off x="6949440" y="1704600"/>
-            <a:ext cx="1828080" cy="119520"/>
+            <a:ext cx="1827720" cy="119160"/>
           </a:xfrm>
           <a:prstGeom prst="rect">
             <a:avLst/>
@@ -8558,7 +8244,7 @@
         <p:spPr>
           <a:xfrm>
             <a:off x="887040" y="1994760"/>
-            <a:ext cx="145440" cy="14040"/>
+            <a:ext cx="145080" cy="13680"/>
           </a:xfrm>
           <a:prstGeom prst="rect">
             <a:avLst/>
@@ -8607,7 +8293,7 @@
         <p:spPr>
           <a:xfrm>
             <a:off x="1069920" y="1916280"/>
-            <a:ext cx="5888160" cy="183600"/>
+            <a:ext cx="5887800" cy="183240"/>
           </a:xfrm>
           <a:prstGeom prst="rect">
             <a:avLst/>
@@ -8664,7 +8350,7 @@
         <p:spPr>
           <a:xfrm>
             <a:off x="6949440" y="1934640"/>
-            <a:ext cx="1828080" cy="119520"/>
+            <a:ext cx="1827720" cy="119160"/>
           </a:xfrm>
           <a:prstGeom prst="rect">
             <a:avLst/>
@@ -8713,7 +8399,7 @@
         <p:spPr>
           <a:xfrm>
             <a:off x="6949440" y="1934640"/>
-            <a:ext cx="1828080" cy="119520"/>
+            <a:ext cx="1827720" cy="119160"/>
           </a:xfrm>
           <a:prstGeom prst="rect">
             <a:avLst/>
@@ -8770,7 +8456,7 @@
         <p:spPr>
           <a:xfrm>
             <a:off x="658440" y="2224440"/>
-            <a:ext cx="145440" cy="14040"/>
+            <a:ext cx="145080" cy="13680"/>
           </a:xfrm>
           <a:prstGeom prst="rect">
             <a:avLst/>
@@ -8819,7 +8505,7 @@
         <p:spPr>
           <a:xfrm>
             <a:off x="841320" y="2146320"/>
-            <a:ext cx="6089040" cy="183600"/>
+            <a:ext cx="6088680" cy="183240"/>
           </a:xfrm>
           <a:prstGeom prst="rect">
             <a:avLst/>
@@ -8876,7 +8562,7 @@
         <p:spPr>
           <a:xfrm>
             <a:off x="6949440" y="2164680"/>
-            <a:ext cx="1828080" cy="119520"/>
+            <a:ext cx="1827720" cy="119160"/>
           </a:xfrm>
           <a:prstGeom prst="rect">
             <a:avLst/>
@@ -8925,7 +8611,7 @@
         <p:spPr>
           <a:xfrm>
             <a:off x="6949440" y="2164680"/>
-            <a:ext cx="1828080" cy="119520"/>
+            <a:ext cx="1827720" cy="119160"/>
           </a:xfrm>
           <a:prstGeom prst="rect">
             <a:avLst/>
@@ -8982,7 +8668,7 @@
         <p:spPr>
           <a:xfrm>
             <a:off x="658440" y="2454480"/>
-            <a:ext cx="145440" cy="14040"/>
+            <a:ext cx="145080" cy="13680"/>
           </a:xfrm>
           <a:prstGeom prst="rect">
             <a:avLst/>
@@ -9031,7 +8717,7 @@
         <p:spPr>
           <a:xfrm>
             <a:off x="841320" y="2376000"/>
-            <a:ext cx="6089040" cy="183600"/>
+            <a:ext cx="6088680" cy="183240"/>
           </a:xfrm>
           <a:prstGeom prst="rect">
             <a:avLst/>
@@ -9088,7 +8774,7 @@
         <p:spPr>
           <a:xfrm>
             <a:off x="6949440" y="2394360"/>
-            <a:ext cx="1828080" cy="119520"/>
+            <a:ext cx="1827720" cy="119160"/>
           </a:xfrm>
           <a:prstGeom prst="rect">
             <a:avLst/>
@@ -9137,7 +8823,7 @@
         <p:spPr>
           <a:xfrm>
             <a:off x="6949440" y="2394360"/>
-            <a:ext cx="1828080" cy="119520"/>
+            <a:ext cx="1827720" cy="119160"/>
           </a:xfrm>
           <a:prstGeom prst="rect">
             <a:avLst/>
@@ -9194,7 +8880,7 @@
         <p:spPr>
           <a:xfrm>
             <a:off x="365760" y="2716200"/>
-            <a:ext cx="8430120" cy="1919880"/>
+            <a:ext cx="8429760" cy="1919520"/>
           </a:xfrm>
           <a:prstGeom prst="rect">
             <a:avLst/>
@@ -9243,7 +8929,7 @@
         <p:spPr>
           <a:xfrm>
             <a:off x="365760" y="4700520"/>
-            <a:ext cx="8430120" cy="200520"/>
+            <a:ext cx="8429760" cy="200160"/>
           </a:xfrm>
           <a:prstGeom prst="rect">
             <a:avLst/>
@@ -9304,7 +8990,7 @@
         <p:spPr>
           <a:xfrm>
             <a:off x="6480" y="2700000"/>
-            <a:ext cx="9143640" cy="1917000"/>
+            <a:ext cx="9143280" cy="1916640"/>
           </a:xfrm>
           <a:prstGeom prst="rect">
             <a:avLst/>
@@ -9360,7 +9046,7 @@
         <p:spPr>
           <a:xfrm>
             <a:off x="365760" y="274320"/>
-            <a:ext cx="45000" cy="529560"/>
+            <a:ext cx="44640" cy="529200"/>
           </a:xfrm>
           <a:prstGeom prst="rect">
             <a:avLst/>
@@ -9409,7 +9095,7 @@
         <p:spPr>
           <a:xfrm>
             <a:off x="502920" y="255960"/>
-            <a:ext cx="8320320" cy="593640"/>
+            <a:ext cx="8319960" cy="593280"/>
           </a:xfrm>
           <a:prstGeom prst="rect">
             <a:avLst/>
@@ -9466,7 +9152,7 @@
         <p:spPr>
           <a:xfrm>
             <a:off x="365760" y="877680"/>
-            <a:ext cx="8411760" cy="19440"/>
+            <a:ext cx="8411400" cy="19080"/>
           </a:xfrm>
           <a:prstGeom prst="rect">
             <a:avLst/>
@@ -9515,7 +9201,7 @@
         <p:spPr>
           <a:xfrm>
             <a:off x="0" y="4906080"/>
-            <a:ext cx="9143280" cy="236880"/>
+            <a:ext cx="9142920" cy="236520"/>
           </a:xfrm>
           <a:prstGeom prst="rect">
             <a:avLst/>
@@ -9564,7 +9250,7 @@
         <p:spPr>
           <a:xfrm>
             <a:off x="365760" y="4906080"/>
-            <a:ext cx="8411760" cy="236880"/>
+            <a:ext cx="8411400" cy="236520"/>
           </a:xfrm>
           <a:prstGeom prst="rect">
             <a:avLst/>
@@ -9621,7 +9307,7 @@
         <p:spPr>
           <a:xfrm>
             <a:off x="365760" y="1005840"/>
-            <a:ext cx="2925360" cy="365040"/>
+            <a:ext cx="2925000" cy="364680"/>
           </a:xfrm>
           <a:prstGeom prst="rect">
             <a:avLst/>
@@ -9670,7 +9356,7 @@
         <p:spPr>
           <a:xfrm>
             <a:off x="438840" y="1005840"/>
-            <a:ext cx="2833920" cy="365040"/>
+            <a:ext cx="2833560" cy="364680"/>
           </a:xfrm>
           <a:prstGeom prst="rect">
             <a:avLst/>
@@ -9727,7 +9413,7 @@
         <p:spPr>
           <a:xfrm>
             <a:off x="3383280" y="1005840"/>
-            <a:ext cx="1005120" cy="365040"/>
+            <a:ext cx="1004760" cy="364680"/>
           </a:xfrm>
           <a:prstGeom prst="rect">
             <a:avLst/>
@@ -9776,7 +9462,7 @@
         <p:spPr>
           <a:xfrm>
             <a:off x="3456360" y="1005840"/>
-            <a:ext cx="913680" cy="365040"/>
+            <a:ext cx="913320" cy="364680"/>
           </a:xfrm>
           <a:prstGeom prst="rect">
             <a:avLst/>
@@ -9833,7 +9519,7 @@
         <p:spPr>
           <a:xfrm>
             <a:off x="4480560" y="1005840"/>
-            <a:ext cx="4571280" cy="365040"/>
+            <a:ext cx="4570920" cy="364680"/>
           </a:xfrm>
           <a:prstGeom prst="rect">
             <a:avLst/>
@@ -9882,7 +9568,7 @@
         <p:spPr>
           <a:xfrm>
             <a:off x="4553640" y="1005840"/>
-            <a:ext cx="4479840" cy="365040"/>
+            <a:ext cx="4479480" cy="364680"/>
           </a:xfrm>
           <a:prstGeom prst="rect">
             <a:avLst/>
@@ -9939,7 +9625,7 @@
         <p:spPr>
           <a:xfrm>
             <a:off x="365760" y="1408320"/>
-            <a:ext cx="2925360" cy="712440"/>
+            <a:ext cx="2925000" cy="712080"/>
           </a:xfrm>
           <a:prstGeom prst="rect">
             <a:avLst/>
@@ -9988,7 +9674,7 @@
         <p:spPr>
           <a:xfrm>
             <a:off x="457200" y="1408320"/>
-            <a:ext cx="2797200" cy="712440"/>
+            <a:ext cx="2796840" cy="712080"/>
           </a:xfrm>
           <a:prstGeom prst="rect">
             <a:avLst/>
@@ -10045,7 +9731,7 @@
         <p:spPr>
           <a:xfrm>
             <a:off x="3383280" y="1408320"/>
-            <a:ext cx="1005120" cy="712440"/>
+            <a:ext cx="1004760" cy="712080"/>
           </a:xfrm>
           <a:prstGeom prst="rect">
             <a:avLst/>
@@ -10094,7 +9780,7 @@
         <p:spPr>
           <a:xfrm>
             <a:off x="3474720" y="1408320"/>
-            <a:ext cx="876960" cy="712440"/>
+            <a:ext cx="876600" cy="712080"/>
           </a:xfrm>
           <a:prstGeom prst="rect">
             <a:avLst/>
@@ -10151,7 +9837,7 @@
         <p:spPr>
           <a:xfrm>
             <a:off x="4480560" y="1408320"/>
-            <a:ext cx="4571280" cy="712440"/>
+            <a:ext cx="4570920" cy="712080"/>
           </a:xfrm>
           <a:prstGeom prst="rect">
             <a:avLst/>
@@ -10200,7 +9886,7 @@
         <p:spPr>
           <a:xfrm>
             <a:off x="4572000" y="1408320"/>
-            <a:ext cx="4443120" cy="712440"/>
+            <a:ext cx="4442760" cy="712080"/>
           </a:xfrm>
           <a:prstGeom prst="rect">
             <a:avLst/>
@@ -10257,7 +9943,7 @@
         <p:spPr>
           <a:xfrm>
             <a:off x="365760" y="2157840"/>
-            <a:ext cx="2925360" cy="712440"/>
+            <a:ext cx="2925000" cy="712080"/>
           </a:xfrm>
           <a:prstGeom prst="rect">
             <a:avLst/>
@@ -10306,7 +9992,7 @@
         <p:spPr>
           <a:xfrm>
             <a:off x="457200" y="2157840"/>
-            <a:ext cx="2797200" cy="712440"/>
+            <a:ext cx="2796840" cy="712080"/>
           </a:xfrm>
           <a:prstGeom prst="rect">
             <a:avLst/>
@@ -10363,7 +10049,7 @@
         <p:spPr>
           <a:xfrm>
             <a:off x="3383280" y="2157840"/>
-            <a:ext cx="1005120" cy="712440"/>
+            <a:ext cx="1004760" cy="712080"/>
           </a:xfrm>
           <a:prstGeom prst="rect">
             <a:avLst/>
@@ -10412,7 +10098,7 @@
         <p:spPr>
           <a:xfrm>
             <a:off x="3474720" y="2157840"/>
-            <a:ext cx="876960" cy="712440"/>
+            <a:ext cx="876600" cy="712080"/>
           </a:xfrm>
           <a:prstGeom prst="rect">
             <a:avLst/>
@@ -10469,7 +10155,7 @@
         <p:spPr>
           <a:xfrm>
             <a:off x="4480560" y="2157840"/>
-            <a:ext cx="4571280" cy="712440"/>
+            <a:ext cx="4570920" cy="712080"/>
           </a:xfrm>
           <a:prstGeom prst="rect">
             <a:avLst/>
@@ -10518,7 +10204,7 @@
         <p:spPr>
           <a:xfrm>
             <a:off x="4572000" y="2157840"/>
-            <a:ext cx="4443120" cy="712440"/>
+            <a:ext cx="4442760" cy="712080"/>
           </a:xfrm>
           <a:prstGeom prst="rect">
             <a:avLst/>
@@ -10575,7 +10261,7 @@
         <p:spPr>
           <a:xfrm>
             <a:off x="365760" y="2908080"/>
-            <a:ext cx="2925360" cy="712440"/>
+            <a:ext cx="2925000" cy="712080"/>
           </a:xfrm>
           <a:prstGeom prst="rect">
             <a:avLst/>
@@ -10624,7 +10310,7 @@
         <p:spPr>
           <a:xfrm>
             <a:off x="457200" y="2908080"/>
-            <a:ext cx="2797200" cy="712440"/>
+            <a:ext cx="2796840" cy="712080"/>
           </a:xfrm>
           <a:prstGeom prst="rect">
             <a:avLst/>
@@ -10681,7 +10367,7 @@
         <p:spPr>
           <a:xfrm>
             <a:off x="3383280" y="2908080"/>
-            <a:ext cx="1005120" cy="712440"/>
+            <a:ext cx="1004760" cy="712080"/>
           </a:xfrm>
           <a:prstGeom prst="rect">
             <a:avLst/>
@@ -10730,7 +10416,7 @@
         <p:spPr>
           <a:xfrm>
             <a:off x="3474720" y="2908080"/>
-            <a:ext cx="876960" cy="712440"/>
+            <a:ext cx="876600" cy="712080"/>
           </a:xfrm>
           <a:prstGeom prst="rect">
             <a:avLst/>
@@ -10787,7 +10473,7 @@
         <p:spPr>
           <a:xfrm>
             <a:off x="4480560" y="2908080"/>
-            <a:ext cx="4571280" cy="712440"/>
+            <a:ext cx="4570920" cy="712080"/>
           </a:xfrm>
           <a:prstGeom prst="rect">
             <a:avLst/>
@@ -10836,7 +10522,7 @@
         <p:spPr>
           <a:xfrm>
             <a:off x="4572000" y="2908080"/>
-            <a:ext cx="4443120" cy="712440"/>
+            <a:ext cx="4442760" cy="712080"/>
           </a:xfrm>
           <a:prstGeom prst="rect">
             <a:avLst/>
@@ -10893,7 +10579,7 @@
         <p:spPr>
           <a:xfrm>
             <a:off x="365760" y="4298040"/>
-            <a:ext cx="8411760" cy="346680"/>
+            <a:ext cx="8411400" cy="346320"/>
           </a:xfrm>
           <a:prstGeom prst="rect">
             <a:avLst/>
@@ -10942,7 +10628,7 @@
         <p:spPr>
           <a:xfrm>
             <a:off x="530280" y="4298040"/>
-            <a:ext cx="8137440" cy="346680"/>
+            <a:ext cx="8137080" cy="346320"/>
           </a:xfrm>
           <a:prstGeom prst="rect">
             <a:avLst/>
@@ -11036,7 +10722,7 @@
         <p:spPr>
           <a:xfrm>
             <a:off x="365760" y="274320"/>
-            <a:ext cx="45000" cy="529560"/>
+            <a:ext cx="44640" cy="529200"/>
           </a:xfrm>
           <a:prstGeom prst="rect">
             <a:avLst/>
@@ -11085,7 +10771,7 @@
         <p:spPr>
           <a:xfrm>
             <a:off x="502920" y="255960"/>
-            <a:ext cx="8320320" cy="593640"/>
+            <a:ext cx="8319960" cy="593280"/>
           </a:xfrm>
           <a:prstGeom prst="rect">
             <a:avLst/>
@@ -11142,7 +10828,7 @@
         <p:spPr>
           <a:xfrm>
             <a:off x="365760" y="877680"/>
-            <a:ext cx="8411760" cy="19440"/>
+            <a:ext cx="8411400" cy="19080"/>
           </a:xfrm>
           <a:prstGeom prst="rect">
             <a:avLst/>
@@ -11191,7 +10877,7 @@
         <p:spPr>
           <a:xfrm>
             <a:off x="0" y="4906080"/>
-            <a:ext cx="9143280" cy="236880"/>
+            <a:ext cx="9142920" cy="236520"/>
           </a:xfrm>
           <a:prstGeom prst="rect">
             <a:avLst/>
@@ -11240,7 +10926,7 @@
         <p:spPr>
           <a:xfrm>
             <a:off x="365760" y="4906080"/>
-            <a:ext cx="8411760" cy="236880"/>
+            <a:ext cx="8411400" cy="236520"/>
           </a:xfrm>
           <a:prstGeom prst="rect">
             <a:avLst/>
@@ -11297,7 +10983,7 @@
         <p:spPr>
           <a:xfrm>
             <a:off x="365760" y="987480"/>
-            <a:ext cx="4159800" cy="3062880"/>
+            <a:ext cx="4159440" cy="3062520"/>
           </a:xfrm>
           <a:prstGeom prst="rect">
             <a:avLst/>
@@ -11346,7 +11032,7 @@
         <p:spPr>
           <a:xfrm>
             <a:off x="365760" y="987480"/>
-            <a:ext cx="4159800" cy="36000"/>
+            <a:ext cx="4159440" cy="35640"/>
           </a:xfrm>
           <a:prstGeom prst="rect">
             <a:avLst/>
@@ -11395,7 +11081,7 @@
         <p:spPr>
           <a:xfrm>
             <a:off x="511920" y="1078920"/>
-            <a:ext cx="3940200" cy="346680"/>
+            <a:ext cx="3939840" cy="346320"/>
           </a:xfrm>
           <a:prstGeom prst="rect">
             <a:avLst/>
@@ -11452,7 +11138,7 @@
         <p:spPr>
           <a:xfrm>
             <a:off x="511920" y="1682640"/>
-            <a:ext cx="81720" cy="81720"/>
+            <a:ext cx="81360" cy="81360"/>
           </a:xfrm>
           <a:prstGeom prst="ellipse">
             <a:avLst/>
@@ -11501,7 +11187,7 @@
         <p:spPr>
           <a:xfrm>
             <a:off x="658440" y="1554480"/>
-            <a:ext cx="3757320" cy="749160"/>
+            <a:ext cx="3756960" cy="748800"/>
           </a:xfrm>
           <a:prstGeom prst="rect">
             <a:avLst/>
@@ -11558,7 +11244,7 @@
         <p:spPr>
           <a:xfrm>
             <a:off x="511920" y="2487240"/>
-            <a:ext cx="81720" cy="81720"/>
+            <a:ext cx="81360" cy="81360"/>
           </a:xfrm>
           <a:prstGeom prst="ellipse">
             <a:avLst/>
@@ -11607,7 +11293,7 @@
         <p:spPr>
           <a:xfrm>
             <a:off x="658440" y="2359080"/>
-            <a:ext cx="3757320" cy="749160"/>
+            <a:ext cx="3756960" cy="748800"/>
           </a:xfrm>
           <a:prstGeom prst="rect">
             <a:avLst/>
@@ -11664,7 +11350,7 @@
         <p:spPr>
           <a:xfrm>
             <a:off x="511920" y="3292200"/>
-            <a:ext cx="81720" cy="81720"/>
+            <a:ext cx="81360" cy="81360"/>
           </a:xfrm>
           <a:prstGeom prst="ellipse">
             <a:avLst/>
@@ -11713,7 +11399,7 @@
         <p:spPr>
           <a:xfrm>
             <a:off x="658440" y="3164040"/>
-            <a:ext cx="3757320" cy="749160"/>
+            <a:ext cx="3756960" cy="748800"/>
           </a:xfrm>
           <a:prstGeom prst="rect">
             <a:avLst/>
@@ -11770,7 +11456,7 @@
         <p:spPr>
           <a:xfrm>
             <a:off x="4754880" y="987480"/>
-            <a:ext cx="4159800" cy="3062880"/>
+            <a:ext cx="4159440" cy="3062520"/>
           </a:xfrm>
           <a:prstGeom prst="rect">
             <a:avLst/>
@@ -11819,7 +11505,7 @@
         <p:spPr>
           <a:xfrm>
             <a:off x="4754880" y="987480"/>
-            <a:ext cx="4159800" cy="36000"/>
+            <a:ext cx="4159440" cy="35640"/>
           </a:xfrm>
           <a:prstGeom prst="rect">
             <a:avLst/>
@@ -11868,7 +11554,7 @@
         <p:spPr>
           <a:xfrm>
             <a:off x="4901040" y="1078920"/>
-            <a:ext cx="3940200" cy="346680"/>
+            <a:ext cx="3939840" cy="346320"/>
           </a:xfrm>
           <a:prstGeom prst="rect">
             <a:avLst/>
@@ -11925,7 +11611,7 @@
         <p:spPr>
           <a:xfrm>
             <a:off x="4901040" y="1682640"/>
-            <a:ext cx="81720" cy="81720"/>
+            <a:ext cx="81360" cy="81360"/>
           </a:xfrm>
           <a:prstGeom prst="ellipse">
             <a:avLst/>
@@ -11974,7 +11660,7 @@
         <p:spPr>
           <a:xfrm>
             <a:off x="5047560" y="1554480"/>
-            <a:ext cx="3757320" cy="749160"/>
+            <a:ext cx="3756960" cy="748800"/>
           </a:xfrm>
           <a:prstGeom prst="rect">
             <a:avLst/>
@@ -12031,7 +11717,7 @@
         <p:spPr>
           <a:xfrm>
             <a:off x="4901040" y="2487240"/>
-            <a:ext cx="81720" cy="81720"/>
+            <a:ext cx="81360" cy="81360"/>
           </a:xfrm>
           <a:prstGeom prst="ellipse">
             <a:avLst/>
@@ -12080,7 +11766,7 @@
         <p:spPr>
           <a:xfrm>
             <a:off x="5047560" y="2359080"/>
-            <a:ext cx="3757320" cy="749160"/>
+            <a:ext cx="3756960" cy="748800"/>
           </a:xfrm>
           <a:prstGeom prst="rect">
             <a:avLst/>
@@ -12137,7 +11823,7 @@
         <p:spPr>
           <a:xfrm>
             <a:off x="4901040" y="3292200"/>
-            <a:ext cx="81720" cy="81720"/>
+            <a:ext cx="81360" cy="81360"/>
           </a:xfrm>
           <a:prstGeom prst="ellipse">
             <a:avLst/>
@@ -12186,7 +11872,7 @@
         <p:spPr>
           <a:xfrm>
             <a:off x="5047560" y="3164040"/>
-            <a:ext cx="3757320" cy="749160"/>
+            <a:ext cx="3756960" cy="748800"/>
           </a:xfrm>
           <a:prstGeom prst="rect">
             <a:avLst/>
@@ -12243,7 +11929,7 @@
         <p:spPr>
           <a:xfrm>
             <a:off x="365760" y="4160880"/>
-            <a:ext cx="8411760" cy="346680"/>
+            <a:ext cx="8411400" cy="346320"/>
           </a:xfrm>
           <a:prstGeom prst="rect">
             <a:avLst/>
@@ -12292,7 +11978,7 @@
         <p:spPr>
           <a:xfrm>
             <a:off x="530280" y="4160880"/>
-            <a:ext cx="8137440" cy="346680"/>
+            <a:ext cx="8137080" cy="346320"/>
           </a:xfrm>
           <a:prstGeom prst="rect">
             <a:avLst/>
@@ -12386,7 +12072,7 @@
         <p:spPr>
           <a:xfrm>
             <a:off x="365760" y="274320"/>
-            <a:ext cx="45000" cy="529560"/>
+            <a:ext cx="44640" cy="529200"/>
           </a:xfrm>
           <a:prstGeom prst="rect">
             <a:avLst/>
@@ -12435,7 +12121,7 @@
         <p:spPr>
           <a:xfrm>
             <a:off x="502920" y="255960"/>
-            <a:ext cx="8320320" cy="593640"/>
+            <a:ext cx="8319960" cy="593280"/>
           </a:xfrm>
           <a:prstGeom prst="rect">
             <a:avLst/>
@@ -12492,7 +12178,7 @@
         <p:spPr>
           <a:xfrm>
             <a:off x="365760" y="877680"/>
-            <a:ext cx="8411760" cy="19440"/>
+            <a:ext cx="8411400" cy="19080"/>
           </a:xfrm>
           <a:prstGeom prst="rect">
             <a:avLst/>
@@ -12541,7 +12227,7 @@
         <p:spPr>
           <a:xfrm>
             <a:off x="0" y="4906080"/>
-            <a:ext cx="9143280" cy="236880"/>
+            <a:ext cx="9142920" cy="236520"/>
           </a:xfrm>
           <a:prstGeom prst="rect">
             <a:avLst/>
@@ -12590,7 +12276,7 @@
         <p:spPr>
           <a:xfrm>
             <a:off x="365760" y="4906080"/>
-            <a:ext cx="8411760" cy="236880"/>
+            <a:ext cx="8411400" cy="236520"/>
           </a:xfrm>
           <a:prstGeom prst="rect">
             <a:avLst/>
@@ -12647,7 +12333,7 @@
         <p:spPr>
           <a:xfrm>
             <a:off x="365760" y="1005840"/>
-            <a:ext cx="2559600" cy="365040"/>
+            <a:ext cx="2559240" cy="364680"/>
           </a:xfrm>
           <a:prstGeom prst="rect">
             <a:avLst/>
@@ -12696,7 +12382,7 @@
         <p:spPr>
           <a:xfrm>
             <a:off x="457200" y="1005840"/>
-            <a:ext cx="2431440" cy="365040"/>
+            <a:ext cx="2431080" cy="364680"/>
           </a:xfrm>
           <a:prstGeom prst="rect">
             <a:avLst/>
@@ -12753,7 +12439,7 @@
         <p:spPr>
           <a:xfrm>
             <a:off x="3017520" y="1005840"/>
-            <a:ext cx="5760000" cy="365040"/>
+            <a:ext cx="5759640" cy="364680"/>
           </a:xfrm>
           <a:prstGeom prst="rect">
             <a:avLst/>
@@ -12802,7 +12488,7 @@
         <p:spPr>
           <a:xfrm>
             <a:off x="3108960" y="1005840"/>
-            <a:ext cx="5631840" cy="365040"/>
+            <a:ext cx="5631480" cy="364680"/>
           </a:xfrm>
           <a:prstGeom prst="rect">
             <a:avLst/>
@@ -12859,7 +12545,7 @@
         <p:spPr>
           <a:xfrm>
             <a:off x="365760" y="1408320"/>
-            <a:ext cx="2559600" cy="621000"/>
+            <a:ext cx="2559240" cy="620640"/>
           </a:xfrm>
           <a:prstGeom prst="rect">
             <a:avLst/>
@@ -12908,7 +12594,7 @@
         <p:spPr>
           <a:xfrm>
             <a:off x="457200" y="1408320"/>
-            <a:ext cx="2431440" cy="621000"/>
+            <a:ext cx="2431080" cy="620640"/>
           </a:xfrm>
           <a:prstGeom prst="rect">
             <a:avLst/>
@@ -12965,7 +12651,7 @@
         <p:spPr>
           <a:xfrm>
             <a:off x="3017520" y="1408320"/>
-            <a:ext cx="5760000" cy="621000"/>
+            <a:ext cx="5759640" cy="620640"/>
           </a:xfrm>
           <a:prstGeom prst="rect">
             <a:avLst/>
@@ -13014,7 +12700,7 @@
         <p:spPr>
           <a:xfrm>
             <a:off x="3108960" y="1408320"/>
-            <a:ext cx="5631840" cy="621000"/>
+            <a:ext cx="5631480" cy="620640"/>
           </a:xfrm>
           <a:prstGeom prst="rect">
             <a:avLst/>
@@ -13071,7 +12757,7 @@
         <p:spPr>
           <a:xfrm>
             <a:off x="365760" y="2066400"/>
-            <a:ext cx="2559600" cy="621000"/>
+            <a:ext cx="2559240" cy="620640"/>
           </a:xfrm>
           <a:prstGeom prst="rect">
             <a:avLst/>
@@ -13120,7 +12806,7 @@
         <p:spPr>
           <a:xfrm>
             <a:off x="457200" y="2066400"/>
-            <a:ext cx="2431440" cy="621000"/>
+            <a:ext cx="2431080" cy="620640"/>
           </a:xfrm>
           <a:prstGeom prst="rect">
             <a:avLst/>
@@ -13177,7 +12863,7 @@
         <p:spPr>
           <a:xfrm>
             <a:off x="3017520" y="2066400"/>
-            <a:ext cx="5760000" cy="621000"/>
+            <a:ext cx="5759640" cy="620640"/>
           </a:xfrm>
           <a:prstGeom prst="rect">
             <a:avLst/>
@@ -13226,7 +12912,7 @@
         <p:spPr>
           <a:xfrm>
             <a:off x="3108960" y="2066400"/>
-            <a:ext cx="5631840" cy="621000"/>
+            <a:ext cx="5631480" cy="620640"/>
           </a:xfrm>
           <a:prstGeom prst="rect">
             <a:avLst/>
@@ -13283,7 +12969,7 @@
         <p:spPr>
           <a:xfrm>
             <a:off x="365760" y="2725200"/>
-            <a:ext cx="2559600" cy="621000"/>
+            <a:ext cx="2559240" cy="620640"/>
           </a:xfrm>
           <a:prstGeom prst="rect">
             <a:avLst/>
@@ -13332,7 +13018,7 @@
         <p:spPr>
           <a:xfrm>
             <a:off x="457200" y="2725200"/>
-            <a:ext cx="2431440" cy="621000"/>
+            <a:ext cx="2431080" cy="620640"/>
           </a:xfrm>
           <a:prstGeom prst="rect">
             <a:avLst/>
@@ -13389,7 +13075,7 @@
         <p:spPr>
           <a:xfrm>
             <a:off x="3017520" y="2725200"/>
-            <a:ext cx="5760000" cy="621000"/>
+            <a:ext cx="5759640" cy="620640"/>
           </a:xfrm>
           <a:prstGeom prst="rect">
             <a:avLst/>
@@ -13438,7 +13124,7 @@
         <p:spPr>
           <a:xfrm>
             <a:off x="3108960" y="2725200"/>
-            <a:ext cx="5631840" cy="621000"/>
+            <a:ext cx="5631480" cy="620640"/>
           </a:xfrm>
           <a:prstGeom prst="rect">
             <a:avLst/>
@@ -13495,7 +13181,7 @@
         <p:spPr>
           <a:xfrm>
             <a:off x="365760" y="3383640"/>
-            <a:ext cx="2559600" cy="621000"/>
+            <a:ext cx="2559240" cy="620640"/>
           </a:xfrm>
           <a:prstGeom prst="rect">
             <a:avLst/>
@@ -13544,7 +13230,7 @@
         <p:spPr>
           <a:xfrm>
             <a:off x="457200" y="3383640"/>
-            <a:ext cx="2431440" cy="621000"/>
+            <a:ext cx="2431080" cy="620640"/>
           </a:xfrm>
           <a:prstGeom prst="rect">
             <a:avLst/>
@@ -13601,7 +13287,7 @@
         <p:spPr>
           <a:xfrm>
             <a:off x="3017520" y="3383640"/>
-            <a:ext cx="5760000" cy="621000"/>
+            <a:ext cx="5759640" cy="620640"/>
           </a:xfrm>
           <a:prstGeom prst="rect">
             <a:avLst/>
@@ -13650,7 +13336,7 @@
         <p:spPr>
           <a:xfrm>
             <a:off x="3108960" y="3383640"/>
-            <a:ext cx="5631840" cy="621000"/>
+            <a:ext cx="5631480" cy="620640"/>
           </a:xfrm>
           <a:prstGeom prst="rect">
             <a:avLst/>
@@ -13707,7 +13393,7 @@
         <p:spPr>
           <a:xfrm>
             <a:off x="365760" y="4160880"/>
-            <a:ext cx="8411760" cy="438120"/>
+            <a:ext cx="8411400" cy="437760"/>
           </a:xfrm>
           <a:prstGeom prst="rect">
             <a:avLst/>
@@ -13756,7 +13442,7 @@
         <p:spPr>
           <a:xfrm>
             <a:off x="502920" y="4160880"/>
-            <a:ext cx="8228880" cy="438120"/>
+            <a:ext cx="8228520" cy="437760"/>
           </a:xfrm>
           <a:prstGeom prst="rect">
             <a:avLst/>
@@ -13850,7 +13536,7 @@
         <p:spPr>
           <a:xfrm>
             <a:off x="365760" y="274320"/>
-            <a:ext cx="45000" cy="529560"/>
+            <a:ext cx="44640" cy="529200"/>
           </a:xfrm>
           <a:prstGeom prst="rect">
             <a:avLst/>
@@ -13899,7 +13585,7 @@
         <p:spPr>
           <a:xfrm>
             <a:off x="502920" y="255960"/>
-            <a:ext cx="8320320" cy="593640"/>
+            <a:ext cx="8319960" cy="593280"/>
           </a:xfrm>
           <a:prstGeom prst="rect">
             <a:avLst/>
@@ -13956,7 +13642,7 @@
         <p:spPr>
           <a:xfrm>
             <a:off x="365760" y="877680"/>
-            <a:ext cx="8411760" cy="19440"/>
+            <a:ext cx="8411400" cy="19080"/>
           </a:xfrm>
           <a:prstGeom prst="rect">
             <a:avLst/>
@@ -14005,7 +13691,7 @@
         <p:spPr>
           <a:xfrm>
             <a:off x="0" y="4906080"/>
-            <a:ext cx="9143280" cy="236880"/>
+            <a:ext cx="9142920" cy="236520"/>
           </a:xfrm>
           <a:prstGeom prst="rect">
             <a:avLst/>
@@ -14054,7 +13740,7 @@
         <p:spPr>
           <a:xfrm>
             <a:off x="365760" y="4906080"/>
-            <a:ext cx="8411760" cy="236880"/>
+            <a:ext cx="8411400" cy="236520"/>
           </a:xfrm>
           <a:prstGeom prst="rect">
             <a:avLst/>
@@ -14111,7 +13797,7 @@
         <p:spPr>
           <a:xfrm>
             <a:off x="365760" y="987480"/>
-            <a:ext cx="2760840" cy="621000"/>
+            <a:ext cx="2760480" cy="620640"/>
           </a:xfrm>
           <a:prstGeom prst="rect">
             <a:avLst/>
@@ -14160,7 +13846,7 @@
         <p:spPr>
           <a:xfrm>
             <a:off x="365760" y="987480"/>
-            <a:ext cx="45000" cy="621000"/>
+            <a:ext cx="44640" cy="620640"/>
           </a:xfrm>
           <a:prstGeom prst="rect">
             <a:avLst/>
@@ -14209,7 +13895,7 @@
         <p:spPr>
           <a:xfrm>
             <a:off x="475560" y="1005840"/>
-            <a:ext cx="2559600" cy="255240"/>
+            <a:ext cx="2559240" cy="254880"/>
           </a:xfrm>
           <a:prstGeom prst="rect">
             <a:avLst/>
@@ -14266,7 +13952,7 @@
         <p:spPr>
           <a:xfrm>
             <a:off x="475560" y="1280160"/>
-            <a:ext cx="2559600" cy="273600"/>
+            <a:ext cx="2559240" cy="273240"/>
           </a:xfrm>
           <a:prstGeom prst="rect">
             <a:avLst/>
@@ -14323,7 +14009,7 @@
         <p:spPr>
           <a:xfrm>
             <a:off x="3310200" y="987480"/>
-            <a:ext cx="2760840" cy="621000"/>
+            <a:ext cx="2760480" cy="620640"/>
           </a:xfrm>
           <a:prstGeom prst="rect">
             <a:avLst/>
@@ -14372,7 +14058,7 @@
         <p:spPr>
           <a:xfrm>
             <a:off x="3310200" y="987480"/>
-            <a:ext cx="45000" cy="621000"/>
+            <a:ext cx="44640" cy="620640"/>
           </a:xfrm>
           <a:prstGeom prst="rect">
             <a:avLst/>
@@ -14421,7 +14107,7 @@
         <p:spPr>
           <a:xfrm>
             <a:off x="3420000" y="1005840"/>
-            <a:ext cx="2559600" cy="255240"/>
+            <a:ext cx="2559240" cy="254880"/>
           </a:xfrm>
           <a:prstGeom prst="rect">
             <a:avLst/>
@@ -14478,7 +14164,7 @@
         <p:spPr>
           <a:xfrm>
             <a:off x="3420000" y="1280160"/>
-            <a:ext cx="2559600" cy="273600"/>
+            <a:ext cx="2559240" cy="273240"/>
           </a:xfrm>
           <a:prstGeom prst="rect">
             <a:avLst/>
@@ -14535,7 +14221,7 @@
         <p:spPr>
           <a:xfrm>
             <a:off x="6254640" y="987480"/>
-            <a:ext cx="2760840" cy="621000"/>
+            <a:ext cx="2760480" cy="620640"/>
           </a:xfrm>
           <a:prstGeom prst="rect">
             <a:avLst/>
@@ -14584,7 +14270,7 @@
         <p:spPr>
           <a:xfrm>
             <a:off x="6254640" y="987480"/>
-            <a:ext cx="45000" cy="621000"/>
+            <a:ext cx="44640" cy="620640"/>
           </a:xfrm>
           <a:prstGeom prst="rect">
             <a:avLst/>
@@ -14633,7 +14319,7 @@
         <p:spPr>
           <a:xfrm>
             <a:off x="6364080" y="1005840"/>
-            <a:ext cx="2559600" cy="255240"/>
+            <a:ext cx="2559240" cy="254880"/>
           </a:xfrm>
           <a:prstGeom prst="rect">
             <a:avLst/>
@@ -14690,7 +14376,7 @@
         <p:spPr>
           <a:xfrm>
             <a:off x="6364080" y="1280160"/>
-            <a:ext cx="2559600" cy="273600"/>
+            <a:ext cx="2559240" cy="273240"/>
           </a:xfrm>
           <a:prstGeom prst="rect">
             <a:avLst/>
@@ -14747,7 +14433,7 @@
         <p:spPr>
           <a:xfrm>
             <a:off x="360000" y="1800000"/>
-            <a:ext cx="8640000" cy="2871000"/>
+            <a:ext cx="8639640" cy="2870640"/>
           </a:xfrm>
           <a:prstGeom prst="rect">
             <a:avLst/>
@@ -14796,7 +14482,7 @@
         <p:spPr>
           <a:xfrm>
             <a:off x="365760" y="4736880"/>
-            <a:ext cx="8411760" cy="163800"/>
+            <a:ext cx="8411400" cy="163440"/>
           </a:xfrm>
           <a:prstGeom prst="rect">
             <a:avLst/>
@@ -14856,8 +14542,8 @@
         </p:blipFill>
         <p:spPr>
           <a:xfrm>
-            <a:off x="943200" y="1872000"/>
-            <a:ext cx="7516800" cy="2723040"/>
+            <a:off x="1656000" y="1872000"/>
+            <a:ext cx="5400000" cy="2745000"/>
           </a:xfrm>
           <a:prstGeom prst="rect">
             <a:avLst/>
@@ -14913,7 +14599,7 @@
         <p:spPr>
           <a:xfrm>
             <a:off x="365760" y="274320"/>
-            <a:ext cx="45000" cy="529560"/>
+            <a:ext cx="44640" cy="529200"/>
           </a:xfrm>
           <a:prstGeom prst="rect">
             <a:avLst/>
@@ -14939,6 +14625,11 @@
             <a:noAutofit/>
           </a:bodyPr>
           <a:p>
+            <a:pPr>
+              <a:lnSpc>
+                <a:spcPct val="100000"/>
+              </a:lnSpc>
+            </a:pPr>
             <a:endParaRPr b="0" lang="pt-PT" sz="1800" spc="-1" strike="noStrike">
               <a:solidFill>
                 <a:srgbClr val="ffffff"/>
@@ -14957,7 +14648,7 @@
         <p:spPr>
           <a:xfrm>
             <a:off x="502920" y="255960"/>
-            <a:ext cx="8320320" cy="593640"/>
+            <a:ext cx="8319960" cy="593280"/>
           </a:xfrm>
           <a:prstGeom prst="rect">
             <a:avLst/>
@@ -15014,7 +14705,7 @@
         <p:spPr>
           <a:xfrm>
             <a:off x="365760" y="877680"/>
-            <a:ext cx="8411760" cy="19440"/>
+            <a:ext cx="8411400" cy="19080"/>
           </a:xfrm>
           <a:prstGeom prst="rect">
             <a:avLst/>
@@ -15040,6 +14731,11 @@
             <a:noAutofit/>
           </a:bodyPr>
           <a:p>
+            <a:pPr>
+              <a:lnSpc>
+                <a:spcPct val="100000"/>
+              </a:lnSpc>
+            </a:pPr>
             <a:endParaRPr b="0" lang="pt-PT" sz="1800" spc="-1" strike="noStrike">
               <a:solidFill>
                 <a:srgbClr val="ffffff"/>
@@ -15058,7 +14754,7 @@
         <p:spPr>
           <a:xfrm>
             <a:off x="0" y="4906080"/>
-            <a:ext cx="9143280" cy="236880"/>
+            <a:ext cx="9142920" cy="236520"/>
           </a:xfrm>
           <a:prstGeom prst="rect">
             <a:avLst/>
@@ -15084,6 +14780,11 @@
             <a:noAutofit/>
           </a:bodyPr>
           <a:p>
+            <a:pPr>
+              <a:lnSpc>
+                <a:spcPct val="100000"/>
+              </a:lnSpc>
+            </a:pPr>
             <a:endParaRPr b="0" lang="pt-PT" sz="1800" spc="-1" strike="noStrike">
               <a:solidFill>
                 <a:srgbClr val="ffffff"/>
@@ -15102,7 +14803,7 @@
         <p:spPr>
           <a:xfrm>
             <a:off x="365760" y="4906080"/>
-            <a:ext cx="8411760" cy="236880"/>
+            <a:ext cx="8411400" cy="236520"/>
           </a:xfrm>
           <a:prstGeom prst="rect">
             <a:avLst/>
@@ -15159,7 +14860,7 @@
         <p:spPr>
           <a:xfrm>
             <a:off x="365760" y="987480"/>
-            <a:ext cx="2760840" cy="621000"/>
+            <a:ext cx="2760480" cy="620640"/>
           </a:xfrm>
           <a:prstGeom prst="rect">
             <a:avLst/>
@@ -15185,6 +14886,11 @@
             <a:noAutofit/>
           </a:bodyPr>
           <a:p>
+            <a:pPr>
+              <a:lnSpc>
+                <a:spcPct val="100000"/>
+              </a:lnSpc>
+            </a:pPr>
             <a:endParaRPr b="0" lang="pt-PT" sz="1800" spc="-1" strike="noStrike">
               <a:solidFill>
                 <a:srgbClr val="ffffff"/>
@@ -15203,7 +14909,7 @@
         <p:spPr>
           <a:xfrm>
             <a:off x="365760" y="987480"/>
-            <a:ext cx="45000" cy="621000"/>
+            <a:ext cx="44640" cy="620640"/>
           </a:xfrm>
           <a:prstGeom prst="rect">
             <a:avLst/>
@@ -15229,6 +14935,11 @@
             <a:noAutofit/>
           </a:bodyPr>
           <a:p>
+            <a:pPr>
+              <a:lnSpc>
+                <a:spcPct val="100000"/>
+              </a:lnSpc>
+            </a:pPr>
             <a:endParaRPr b="0" lang="pt-PT" sz="1800" spc="-1" strike="noStrike">
               <a:solidFill>
                 <a:srgbClr val="ffffff"/>
@@ -15247,7 +14958,7 @@
         <p:spPr>
           <a:xfrm>
             <a:off x="475560" y="1005840"/>
-            <a:ext cx="2559600" cy="255240"/>
+            <a:ext cx="2559240" cy="254880"/>
           </a:xfrm>
           <a:prstGeom prst="rect">
             <a:avLst/>
@@ -15304,7 +15015,7 @@
         <p:spPr>
           <a:xfrm>
             <a:off x="475560" y="1280160"/>
-            <a:ext cx="2559600" cy="273600"/>
+            <a:ext cx="2559240" cy="273240"/>
           </a:xfrm>
           <a:prstGeom prst="rect">
             <a:avLst/>
@@ -15361,7 +15072,7 @@
         <p:spPr>
           <a:xfrm>
             <a:off x="3310200" y="987480"/>
-            <a:ext cx="2760840" cy="621000"/>
+            <a:ext cx="2760480" cy="620640"/>
           </a:xfrm>
           <a:prstGeom prst="rect">
             <a:avLst/>
@@ -15387,6 +15098,11 @@
             <a:noAutofit/>
           </a:bodyPr>
           <a:p>
+            <a:pPr>
+              <a:lnSpc>
+                <a:spcPct val="100000"/>
+              </a:lnSpc>
+            </a:pPr>
             <a:endParaRPr b="0" lang="pt-PT" sz="1800" spc="-1" strike="noStrike">
               <a:solidFill>
                 <a:srgbClr val="ffffff"/>
@@ -15405,7 +15121,7 @@
         <p:spPr>
           <a:xfrm>
             <a:off x="3310200" y="987480"/>
-            <a:ext cx="45000" cy="621000"/>
+            <a:ext cx="44640" cy="620640"/>
           </a:xfrm>
           <a:prstGeom prst="rect">
             <a:avLst/>
@@ -15431,6 +15147,11 @@
             <a:noAutofit/>
           </a:bodyPr>
           <a:p>
+            <a:pPr>
+              <a:lnSpc>
+                <a:spcPct val="100000"/>
+              </a:lnSpc>
+            </a:pPr>
             <a:endParaRPr b="0" lang="pt-PT" sz="1800" spc="-1" strike="noStrike">
               <a:solidFill>
                 <a:srgbClr val="ffffff"/>
@@ -15449,7 +15170,7 @@
         <p:spPr>
           <a:xfrm>
             <a:off x="3420000" y="1005840"/>
-            <a:ext cx="2559600" cy="255240"/>
+            <a:ext cx="2559240" cy="254880"/>
           </a:xfrm>
           <a:prstGeom prst="rect">
             <a:avLst/>
@@ -15506,7 +15227,7 @@
         <p:spPr>
           <a:xfrm>
             <a:off x="3420000" y="1280160"/>
-            <a:ext cx="2559600" cy="273600"/>
+            <a:ext cx="2559240" cy="273240"/>
           </a:xfrm>
           <a:prstGeom prst="rect">
             <a:avLst/>
@@ -15563,7 +15284,7 @@
         <p:spPr>
           <a:xfrm>
             <a:off x="6254640" y="987480"/>
-            <a:ext cx="2760840" cy="621000"/>
+            <a:ext cx="2760480" cy="620640"/>
           </a:xfrm>
           <a:prstGeom prst="rect">
             <a:avLst/>
@@ -15589,6 +15310,11 @@
             <a:noAutofit/>
           </a:bodyPr>
           <a:p>
+            <a:pPr>
+              <a:lnSpc>
+                <a:spcPct val="100000"/>
+              </a:lnSpc>
+            </a:pPr>
             <a:endParaRPr b="0" lang="pt-PT" sz="1800" spc="-1" strike="noStrike">
               <a:solidFill>
                 <a:srgbClr val="ffffff"/>
@@ -15607,7 +15333,7 @@
         <p:spPr>
           <a:xfrm>
             <a:off x="6254640" y="987480"/>
-            <a:ext cx="45000" cy="621000"/>
+            <a:ext cx="44640" cy="620640"/>
           </a:xfrm>
           <a:prstGeom prst="rect">
             <a:avLst/>
@@ -15633,6 +15359,11 @@
             <a:noAutofit/>
           </a:bodyPr>
           <a:p>
+            <a:pPr>
+              <a:lnSpc>
+                <a:spcPct val="100000"/>
+              </a:lnSpc>
+            </a:pPr>
             <a:endParaRPr b="0" lang="pt-PT" sz="1800" spc="-1" strike="noStrike">
               <a:solidFill>
                 <a:srgbClr val="ffffff"/>
@@ -15651,7 +15382,7 @@
         <p:spPr>
           <a:xfrm>
             <a:off x="6364080" y="1005840"/>
-            <a:ext cx="2559600" cy="255240"/>
+            <a:ext cx="2559240" cy="254880"/>
           </a:xfrm>
           <a:prstGeom prst="rect">
             <a:avLst/>
@@ -15708,7 +15439,7 @@
         <p:spPr>
           <a:xfrm>
             <a:off x="6364080" y="1280160"/>
-            <a:ext cx="2559600" cy="273600"/>
+            <a:ext cx="2559240" cy="273240"/>
           </a:xfrm>
           <a:prstGeom prst="rect">
             <a:avLst/>
@@ -15765,7 +15496,7 @@
         <p:spPr>
           <a:xfrm>
             <a:off x="360000" y="1800000"/>
-            <a:ext cx="8640000" cy="2871000"/>
+            <a:ext cx="8639640" cy="2870640"/>
           </a:xfrm>
           <a:prstGeom prst="rect">
             <a:avLst/>
@@ -15791,6 +15522,11 @@
             <a:noAutofit/>
           </a:bodyPr>
           <a:p>
+            <a:pPr>
+              <a:lnSpc>
+                <a:spcPct val="100000"/>
+              </a:lnSpc>
+            </a:pPr>
             <a:endParaRPr b="0" lang="pt-PT" sz="1800" spc="-1" strike="noStrike">
               <a:solidFill>
                 <a:srgbClr val="ffffff"/>
@@ -15809,7 +15545,7 @@
         <p:spPr>
           <a:xfrm>
             <a:off x="365760" y="4736880"/>
-            <a:ext cx="8411760" cy="163800"/>
+            <a:ext cx="8411400" cy="163440"/>
           </a:xfrm>
           <a:prstGeom prst="rect">
             <a:avLst/>
@@ -15870,7 +15606,7 @@
         <p:spPr>
           <a:xfrm>
             <a:off x="900000" y="1944360"/>
-            <a:ext cx="7537320" cy="2555640"/>
+            <a:ext cx="7536960" cy="2555280"/>
           </a:xfrm>
           <a:prstGeom prst="rect">
             <a:avLst/>

</xml_diff>